<commit_message>
Refine results validation documentation and clarify statistical findings
- Updated comments in `05_results_validation.py` to correct the description of the undated flag's relationship with the event log, emphasizing its statistical irrelevance.
- Clarified the interpretation of agreement rates, correcting previous misstatements regarding chance agreement and reinforcing the importance of accurate baseline definitions.

These changes aim to enhance the understanding of model performance and the implications of label coherence in the analysis.
</commit_message>
<xml_diff>
--- a/outputs/AvePoint_Executive_Summary.pptx
+++ b/outputs/AvePoint_Executive_Summary.pptx
@@ -4,15 +4,18 @@
   <p:sldMasterIdLst>
     <p:sldMasterId id="2147483648" r:id="rId1"/>
   </p:sldMasterIdLst>
+  <p:notesMasterIdLst>
+    <p:notesMasterId r:id="rId8"/>
+  </p:notesMasterIdLst>
   <p:sldIdLst>
-    <p:sldId id="256" r:id="rId7"/>
-    <p:sldId id="257" r:id="rId9"/>
-    <p:sldId id="258" r:id="rId10"/>
-    <p:sldId id="259" r:id="rId11"/>
-    <p:sldId id="260" r:id="rId12"/>
-    <p:sldId id="261" r:id="rId13"/>
+    <p:sldId id="256" r:id="rId2"/>
+    <p:sldId id="257" r:id="rId3"/>
+    <p:sldId id="258" r:id="rId4"/>
+    <p:sldId id="259" r:id="rId5"/>
+    <p:sldId id="260" r:id="rId6"/>
+    <p:sldId id="261" r:id="rId7"/>
   </p:sldIdLst>
-  <p:sldSz cx="12191695" cy="6858000" type="screen4x3"/>
+  <p:sldSz cx="12192000" cy="6858000"/>
   <p:notesSz cx="6858000" cy="9144000"/>
   <p:defaultTextStyle>
     <a:defPPr>
@@ -109,11 +112,64 @@
       </a:defRPr>
     </a:lvl9pPr>
   </p:defaultTextStyle>
+  <p:extLst>
+    <p:ext uri="{EFAFB233-063F-42B5-8137-9DF3F51BA10A}">
+      <p15:sldGuideLst xmlns:p15="http://schemas.microsoft.com/office/powerpoint/2012/main">
+        <p15:guide id="1" orient="horz" pos="2160">
+          <p15:clr>
+            <a:srgbClr val="A4A3A4"/>
+          </p15:clr>
+        </p15:guide>
+        <p15:guide id="2" pos="2880">
+          <p15:clr>
+            <a:srgbClr val="A4A3A4"/>
+          </p15:clr>
+        </p15:guide>
+      </p15:sldGuideLst>
+    </p:ext>
+  </p:extLst>
 </p:presentation>
 </file>
 
+<file path=ppt/changesInfos/changesInfo1.xml><?xml version="1.0" encoding="utf-8"?>
+<pc:chgInfo xmlns:a="http://schemas.openxmlformats.org/drawingml/2006/main" xmlns:r="http://schemas.openxmlformats.org/officeDocument/2006/relationships" xmlns:ac="http://schemas.microsoft.com/office/drawing/2013/main/command" xmlns:pc="http://schemas.microsoft.com/office/powerpoint/2013/main/command">
+  <pc:docChgLst>
+    <pc:chgData name="Dmitriy Ratushny" userId="08050032e8047aee" providerId="LiveId" clId="{78EB1A6D-D3A9-4525-A4D5-A50D4E20D487}"/>
+    <pc:docChg chg="modSld">
+      <pc:chgData name="Dmitriy Ratushny" userId="08050032e8047aee" providerId="LiveId" clId="{78EB1A6D-D3A9-4525-A4D5-A50D4E20D487}" dt="2026-07-28T17:18:55.324" v="31" actId="20577"/>
+      <pc:docMkLst>
+        <pc:docMk/>
+      </pc:docMkLst>
+      <pc:sldChg chg="modSp mod">
+        <pc:chgData name="Dmitriy Ratushny" userId="08050032e8047aee" providerId="LiveId" clId="{78EB1A6D-D3A9-4525-A4D5-A50D4E20D487}" dt="2026-07-28T17:18:55.324" v="31" actId="20577"/>
+        <pc:sldMkLst>
+          <pc:docMk/>
+          <pc:sldMk cId="0" sldId="256"/>
+        </pc:sldMkLst>
+        <pc:spChg chg="mod">
+          <ac:chgData name="Dmitriy Ratushny" userId="08050032e8047aee" providerId="LiveId" clId="{78EB1A6D-D3A9-4525-A4D5-A50D4E20D487}" dt="2026-07-28T17:18:15.705" v="3" actId="20577"/>
+          <ac:spMkLst>
+            <pc:docMk/>
+            <pc:sldMk cId="0" sldId="256"/>
+            <ac:spMk id="2" creationId="{00000000-0000-0000-0000-000000000000}"/>
+          </ac:spMkLst>
+        </pc:spChg>
+        <pc:spChg chg="mod">
+          <ac:chgData name="Dmitriy Ratushny" userId="08050032e8047aee" providerId="LiveId" clId="{78EB1A6D-D3A9-4525-A4D5-A50D4E20D487}" dt="2026-07-28T17:18:55.324" v="31" actId="20577"/>
+          <ac:spMkLst>
+            <pc:docMk/>
+            <pc:sldMk cId="0" sldId="256"/>
+            <ac:spMk id="3" creationId="{00000000-0000-0000-0000-000000000000}"/>
+          </ac:spMkLst>
+        </pc:spChg>
+      </pc:sldChg>
+    </pc:docChg>
+  </pc:docChgLst>
+</pc:chgInfo>
+</file>
+
 <file path=ppt/notesMasters/notesMaster1.xml><?xml version="1.0" encoding="utf-8"?>
-<p:notesMaster xmlns:a="http://schemas.openxmlformats.org/drawingml/2006/main" xmlns:p="http://schemas.openxmlformats.org/presentationml/2006/main" xmlns:r="http://schemas.openxmlformats.org/officeDocument/2006/relationships">
+<p:notesMaster xmlns:a="http://schemas.openxmlformats.org/drawingml/2006/main" xmlns:r="http://schemas.openxmlformats.org/officeDocument/2006/relationships" xmlns:p="http://schemas.openxmlformats.org/presentationml/2006/main">
   <p:cSld>
     <p:bg>
       <p:bgRef idx="1001">
@@ -134,241 +190,16 @@
           <a:chExt cx="0" cy="0"/>
         </a:xfrm>
       </p:grpSpPr>
-      <p:sp>
-        <p:nvSpPr>
-          <p:cNvPr id="2" name="Header Placeholder 1"/>
-          <p:cNvSpPr>
-            <a:spLocks noGrp="1"/>
-          </p:cNvSpPr>
-          <p:nvPr>
-            <p:ph type="hdr" sz="quarter"/>
-          </p:nvPr>
-        </p:nvSpPr>
-        <p:spPr>
-          <a:xfrm>
-            <a:off x="0" y="0"/>
-            <a:ext cx="2971800" cy="457200"/>
-          </a:xfrm>
-          <a:prstGeom prst="rect">
-            <a:avLst/>
-          </a:prstGeom>
-        </p:spPr>
-        <p:txBody>
-          <a:bodyPr vert="horz" lIns="91440" tIns="45720" rIns="91440" bIns="45720" rtlCol="0"/>
-          <a:lstStyle>
-            <a:lvl1pPr algn="l">
-              <a:defRPr sz="1200"/>
-            </a:lvl1pPr>
-          </a:lstStyle>
-          <a:p>
-            <a:endParaRPr lang="en-US"/>
-          </a:p>
-        </p:txBody>
-      </p:sp>
-      <p:sp>
-        <p:nvSpPr>
-          <p:cNvPr id="3" name="Date Placeholder 2"/>
-          <p:cNvSpPr>
-            <a:spLocks noGrp="1"/>
-          </p:cNvSpPr>
-          <p:nvPr>
-            <p:ph type="dt" idx="1"/>
-          </p:nvPr>
-        </p:nvSpPr>
-        <p:spPr>
-          <a:xfrm>
-            <a:off x="3884613" y="0"/>
-            <a:ext cx="2971800" cy="457200"/>
-          </a:xfrm>
-          <a:prstGeom prst="rect">
-            <a:avLst/>
-          </a:prstGeom>
-        </p:spPr>
-        <p:txBody>
-          <a:bodyPr vert="horz" lIns="91440" tIns="45720" rIns="91440" bIns="45720" rtlCol="0"/>
-          <a:lstStyle>
-            <a:lvl1pPr algn="r">
-              <a:defRPr sz="1200"/>
-            </a:lvl1pPr>
-          </a:lstStyle>
-          <a:p>
-            <a:fld id="{0F89C1C7-3DCD-1040-A9CF-14679D8B5DDD}" type="datetimeFigureOut">
-              <a:rPr lang="en-US" smtClean="0"/>
-              <a:t>10/17/16</a:t>
-            </a:fld>
-            <a:endParaRPr lang="en-US"/>
-          </a:p>
-        </p:txBody>
-      </p:sp>
-      <p:sp>
-        <p:nvSpPr>
-          <p:cNvPr id="4" name="Slide Image Placeholder 3"/>
-          <p:cNvSpPr>
-            <a:spLocks noGrp="1" noRot="1" noChangeAspect="1"/>
-          </p:cNvSpPr>
-          <p:nvPr>
-            <p:ph type="sldImg" idx="2"/>
-          </p:nvPr>
-        </p:nvSpPr>
-        <p:spPr>
-          <a:xfrm>
-            <a:off x="1143000" y="685800"/>
-            <a:ext cx="4572000" cy="3429000"/>
-          </a:xfrm>
-          <a:prstGeom prst="rect">
-            <a:avLst/>
-          </a:prstGeom>
-          <a:noFill/>
-          <a:ln w="12700">
-            <a:solidFill>
-              <a:prstClr val="black"/>
-            </a:solidFill>
-          </a:ln>
-        </p:spPr>
-        <p:txBody>
-          <a:bodyPr vert="horz" lIns="91440" tIns="45720" rIns="91440" bIns="45720" rtlCol="0" anchor="ctr"/>
-          <a:lstStyle/>
-          <a:p>
-            <a:endParaRPr lang="en-US"/>
-          </a:p>
-        </p:txBody>
-      </p:sp>
-      <p:sp>
-        <p:nvSpPr>
-          <p:cNvPr id="5" name="Notes Placeholder 4"/>
-          <p:cNvSpPr>
-            <a:spLocks noGrp="1"/>
-          </p:cNvSpPr>
-          <p:nvPr>
-            <p:ph type="body" sz="quarter" idx="3"/>
-          </p:nvPr>
-        </p:nvSpPr>
-        <p:spPr>
-          <a:xfrm>
-            <a:off x="685800" y="4343400"/>
-            <a:ext cx="5486400" cy="4114800"/>
-          </a:xfrm>
-          <a:prstGeom prst="rect">
-            <a:avLst/>
-          </a:prstGeom>
-        </p:spPr>
-        <p:txBody>
-          <a:bodyPr vert="horz" lIns="91440" tIns="45720" rIns="91440" bIns="45720" rtlCol="0"/>
-          <a:lstStyle/>
-          <a:p>
-            <a:pPr lvl="0"/>
-            <a:r>
-              <a:rPr lang="en-US" smtClean="0"/>
-              <a:t>Click to edit Master text styles</a:t>
-            </a:r>
-          </a:p>
-          <a:p>
-            <a:pPr lvl="1"/>
-            <a:r>
-              <a:rPr lang="en-US" smtClean="0"/>
-              <a:t>Second level</a:t>
-            </a:r>
-          </a:p>
-          <a:p>
-            <a:pPr lvl="2"/>
-            <a:r>
-              <a:rPr lang="en-US" smtClean="0"/>
-              <a:t>Third level</a:t>
-            </a:r>
-          </a:p>
-          <a:p>
-            <a:pPr lvl="3"/>
-            <a:r>
-              <a:rPr lang="en-US" smtClean="0"/>
-              <a:t>Fourth level</a:t>
-            </a:r>
-          </a:p>
-          <a:p>
-            <a:pPr lvl="4"/>
-            <a:r>
-              <a:rPr lang="en-US" smtClean="0"/>
-              <a:t>Fifth level</a:t>
-            </a:r>
-            <a:endParaRPr lang="en-US"/>
-          </a:p>
-        </p:txBody>
-      </p:sp>
-      <p:sp>
-        <p:nvSpPr>
-          <p:cNvPr id="6" name="Footer Placeholder 5"/>
-          <p:cNvSpPr>
-            <a:spLocks noGrp="1"/>
-          </p:cNvSpPr>
-          <p:nvPr>
-            <p:ph type="ftr" sz="quarter" idx="4"/>
-          </p:nvPr>
-        </p:nvSpPr>
-        <p:spPr>
-          <a:xfrm>
-            <a:off x="0" y="8685213"/>
-            <a:ext cx="2971800" cy="457200"/>
-          </a:xfrm>
-          <a:prstGeom prst="rect">
-            <a:avLst/>
-          </a:prstGeom>
-        </p:spPr>
-        <p:txBody>
-          <a:bodyPr vert="horz" lIns="91440" tIns="45720" rIns="91440" bIns="45720" rtlCol="0" anchor="b"/>
-          <a:lstStyle>
-            <a:lvl1pPr algn="l">
-              <a:defRPr sz="1200"/>
-            </a:lvl1pPr>
-          </a:lstStyle>
-          <a:p>
-            <a:endParaRPr lang="en-US"/>
-          </a:p>
-        </p:txBody>
-      </p:sp>
-      <p:sp>
-        <p:nvSpPr>
-          <p:cNvPr id="7" name="Slide Number Placeholder 6"/>
-          <p:cNvSpPr>
-            <a:spLocks noGrp="1"/>
-          </p:cNvSpPr>
-          <p:nvPr>
-            <p:ph type="sldNum" sz="quarter" idx="5"/>
-          </p:nvPr>
-        </p:nvSpPr>
-        <p:spPr>
-          <a:xfrm>
-            <a:off x="3884613" y="8685213"/>
-            <a:ext cx="2971800" cy="457200"/>
-          </a:xfrm>
-          <a:prstGeom prst="rect">
-            <a:avLst/>
-          </a:prstGeom>
-        </p:spPr>
-        <p:txBody>
-          <a:bodyPr vert="horz" lIns="91440" tIns="45720" rIns="91440" bIns="45720" rtlCol="0" anchor="b"/>
-          <a:lstStyle>
-            <a:lvl1pPr algn="r">
-              <a:defRPr sz="1200"/>
-            </a:lvl1pPr>
-          </a:lstStyle>
-          <a:p>
-            <a:fld id="{BB5E49A5-4136-284D-997B-48E1D791AD67}" type="slidenum">
-              <a:rPr lang="en-US" smtClean="0"/>
-              <a:t>‹#›</a:t>
-            </a:fld>
-            <a:endParaRPr lang="en-US"/>
-          </a:p>
-        </p:txBody>
-      </p:sp>
     </p:spTree>
     <p:extLst>
       <p:ext uri="{BB962C8B-B14F-4D97-AF65-F5344CB8AC3E}">
-        <p14:creationId xmlns:p14="http://schemas.microsoft.com/office/powerpoint/2010/main" val="2623252185"/>
+        <p14:creationId xmlns:p14="http://schemas.microsoft.com/office/powerpoint/2010/main" val="1303840188"/>
       </p:ext>
     </p:extLst>
   </p:cSld>
   <p:clrMap bg1="lt1" tx1="dk1" bg2="lt2" tx2="dk2" accent1="accent1" accent2="accent2" accent3="accent3" accent4="accent4" accent5="accent5" accent6="accent6" hlink="hlink" folHlink="folHlink"/>
   <p:notesStyle>
-    <a:lvl1pPr marL="0" algn="l" defTabSz="457200" rtl="0" eaLnBrk="1" latinLnBrk="0" hangingPunct="1">
+    <a:lvl1pPr marL="0" algn="l" defTabSz="914400" rtl="0" eaLnBrk="1" latinLnBrk="0" hangingPunct="1">
       <a:defRPr sz="1200" kern="1200">
         <a:solidFill>
           <a:schemeClr val="tx1"/>
@@ -378,7 +209,7 @@
         <a:cs typeface="+mn-cs"/>
       </a:defRPr>
     </a:lvl1pPr>
-    <a:lvl2pPr marL="457200" algn="l" defTabSz="457200" rtl="0" eaLnBrk="1" latinLnBrk="0" hangingPunct="1">
+    <a:lvl2pPr marL="457200" algn="l" defTabSz="914400" rtl="0" eaLnBrk="1" latinLnBrk="0" hangingPunct="1">
       <a:defRPr sz="1200" kern="1200">
         <a:solidFill>
           <a:schemeClr val="tx1"/>
@@ -388,7 +219,7 @@
         <a:cs typeface="+mn-cs"/>
       </a:defRPr>
     </a:lvl2pPr>
-    <a:lvl3pPr marL="914400" algn="l" defTabSz="457200" rtl="0" eaLnBrk="1" latinLnBrk="0" hangingPunct="1">
+    <a:lvl3pPr marL="914400" algn="l" defTabSz="914400" rtl="0" eaLnBrk="1" latinLnBrk="0" hangingPunct="1">
       <a:defRPr sz="1200" kern="1200">
         <a:solidFill>
           <a:schemeClr val="tx1"/>
@@ -398,7 +229,7 @@
         <a:cs typeface="+mn-cs"/>
       </a:defRPr>
     </a:lvl3pPr>
-    <a:lvl4pPr marL="1371600" algn="l" defTabSz="457200" rtl="0" eaLnBrk="1" latinLnBrk="0" hangingPunct="1">
+    <a:lvl4pPr marL="1371600" algn="l" defTabSz="914400" rtl="0" eaLnBrk="1" latinLnBrk="0" hangingPunct="1">
       <a:defRPr sz="1200" kern="1200">
         <a:solidFill>
           <a:schemeClr val="tx1"/>
@@ -408,7 +239,7 @@
         <a:cs typeface="+mn-cs"/>
       </a:defRPr>
     </a:lvl4pPr>
-    <a:lvl5pPr marL="1828800" algn="l" defTabSz="457200" rtl="0" eaLnBrk="1" latinLnBrk="0" hangingPunct="1">
+    <a:lvl5pPr marL="1828800" algn="l" defTabSz="914400" rtl="0" eaLnBrk="1" latinLnBrk="0" hangingPunct="1">
       <a:defRPr sz="1200" kern="1200">
         <a:solidFill>
           <a:schemeClr val="tx1"/>
@@ -418,7 +249,7 @@
         <a:cs typeface="+mn-cs"/>
       </a:defRPr>
     </a:lvl5pPr>
-    <a:lvl6pPr marL="2286000" algn="l" defTabSz="457200" rtl="0" eaLnBrk="1" latinLnBrk="0" hangingPunct="1">
+    <a:lvl6pPr marL="2286000" algn="l" defTabSz="914400" rtl="0" eaLnBrk="1" latinLnBrk="0" hangingPunct="1">
       <a:defRPr sz="1200" kern="1200">
         <a:solidFill>
           <a:schemeClr val="tx1"/>
@@ -428,7 +259,7 @@
         <a:cs typeface="+mn-cs"/>
       </a:defRPr>
     </a:lvl6pPr>
-    <a:lvl7pPr marL="2743200" algn="l" defTabSz="457200" rtl="0" eaLnBrk="1" latinLnBrk="0" hangingPunct="1">
+    <a:lvl7pPr marL="2743200" algn="l" defTabSz="914400" rtl="0" eaLnBrk="1" latinLnBrk="0" hangingPunct="1">
       <a:defRPr sz="1200" kern="1200">
         <a:solidFill>
           <a:schemeClr val="tx1"/>
@@ -438,7 +269,7 @@
         <a:cs typeface="+mn-cs"/>
       </a:defRPr>
     </a:lvl7pPr>
-    <a:lvl8pPr marL="3200400" algn="l" defTabSz="457200" rtl="0" eaLnBrk="1" latinLnBrk="0" hangingPunct="1">
+    <a:lvl8pPr marL="3200400" algn="l" defTabSz="914400" rtl="0" eaLnBrk="1" latinLnBrk="0" hangingPunct="1">
       <a:defRPr sz="1200" kern="1200">
         <a:solidFill>
           <a:schemeClr val="tx1"/>
@@ -448,7 +279,7 @@
         <a:cs typeface="+mn-cs"/>
       </a:defRPr>
     </a:lvl8pPr>
-    <a:lvl9pPr marL="3657600" algn="l" defTabSz="457200" rtl="0" eaLnBrk="1" latinLnBrk="0" hangingPunct="1">
+    <a:lvl9pPr marL="3657600" algn="l" defTabSz="914400" rtl="0" eaLnBrk="1" latinLnBrk="0" hangingPunct="1">
       <a:defRPr sz="1200" kern="1200">
         <a:solidFill>
           <a:schemeClr val="tx1"/>
@@ -463,7 +294,7 @@
 </file>
 
 <file path=ppt/notesSlides/notesSlide1.xml><?xml version="1.0" encoding="utf-8"?>
-<p:notes xmlns:a="http://schemas.openxmlformats.org/drawingml/2006/main" xmlns:p="http://schemas.openxmlformats.org/presentationml/2006/main" xmlns:r="http://schemas.openxmlformats.org/officeDocument/2006/relationships">
+<p:notes xmlns:a="http://schemas.openxmlformats.org/drawingml/2006/main" xmlns:r="http://schemas.openxmlformats.org/officeDocument/2006/relationships" xmlns:p="http://schemas.openxmlformats.org/presentationml/2006/main">
   <p:cSld>
     <p:spTree>
       <p:nvGrpSpPr>
@@ -483,7 +314,7 @@
         <p:nvSpPr>
           <p:cNvPr id="2" name="Slide Image Placeholder 1"/>
           <p:cNvSpPr>
-            <a:spLocks noGrp="1"/>
+            <a:spLocks noGrp="1" noRot="1" noChangeAspect="1"/>
           </p:cNvSpPr>
           <p:nvPr>
             <p:ph type="sldImg" idx="2"/>
@@ -498,7 +329,7 @@
             <a:spLocks noGrp="1"/>
           </p:cNvSpPr>
           <p:nvPr>
-            <p:ph type="body" idx="3" sz="quarter"/>
+            <p:ph type="body" sz="quarter" idx="3"/>
           </p:nvPr>
         </p:nvSpPr>
         <p:spPr/>
@@ -519,7 +350,7 @@
             <a:spLocks noGrp="1"/>
           </p:cNvSpPr>
           <p:nvPr>
-            <p:ph type="sldNum" idx="5" sz="quarter"/>
+            <p:ph type="sldNum" sz="quarter" idx="5"/>
           </p:nvPr>
         </p:nvSpPr>
         <p:spPr/>
@@ -570,10 +401,9 @@
           <a:lstStyle/>
           <a:p>
             <a:r>
-              <a:rPr lang="en-US" smtClean="0"/>
+              <a:rPr lang="en-US"/>
               <a:t>Click to edit Master title style</a:t>
             </a:r>
-            <a:endParaRPr lang="en-US"/>
           </a:p>
         </p:txBody>
       </p:sp>
@@ -689,10 +519,9 @@
           </a:lstStyle>
           <a:p>
             <a:r>
-              <a:rPr lang="en-US" smtClean="0"/>
+              <a:rPr lang="en-US"/>
               <a:t>Click to edit Master subtitle style</a:t>
             </a:r>
-            <a:endParaRPr lang="en-US"/>
           </a:p>
         </p:txBody>
       </p:sp>
@@ -713,7 +542,7 @@
           <a:p>
             <a:fld id="{5BCAD085-E8A6-8845-BD4E-CB4CCA059FC4}" type="datetimeFigureOut">
               <a:rPr lang="en-US" smtClean="0"/>
-              <a:t>1/27/13</a:t>
+              <a:t>7/28/2026</a:t>
             </a:fld>
             <a:endParaRPr lang="en-US"/>
           </a:p>
@@ -807,10 +636,9 @@
           <a:lstStyle/>
           <a:p>
             <a:r>
-              <a:rPr lang="en-US" smtClean="0"/>
+              <a:rPr lang="en-US"/>
               <a:t>Click to edit Master title style</a:t>
             </a:r>
-            <a:endParaRPr lang="en-US"/>
           </a:p>
         </p:txBody>
       </p:sp>
@@ -831,38 +659,37 @@
           <a:p>
             <a:pPr lvl="0"/>
             <a:r>
-              <a:rPr lang="en-US" smtClean="0"/>
+              <a:rPr lang="en-US"/>
               <a:t>Click to edit Master text styles</a:t>
             </a:r>
           </a:p>
           <a:p>
             <a:pPr lvl="1"/>
             <a:r>
-              <a:rPr lang="en-US" smtClean="0"/>
+              <a:rPr lang="en-US"/>
               <a:t>Second level</a:t>
             </a:r>
           </a:p>
           <a:p>
             <a:pPr lvl="2"/>
             <a:r>
-              <a:rPr lang="en-US" smtClean="0"/>
+              <a:rPr lang="en-US"/>
               <a:t>Third level</a:t>
             </a:r>
           </a:p>
           <a:p>
             <a:pPr lvl="3"/>
             <a:r>
-              <a:rPr lang="en-US" smtClean="0"/>
+              <a:rPr lang="en-US"/>
               <a:t>Fourth level</a:t>
             </a:r>
           </a:p>
           <a:p>
             <a:pPr lvl="4"/>
             <a:r>
-              <a:rPr lang="en-US" smtClean="0"/>
+              <a:rPr lang="en-US"/>
               <a:t>Fifth level</a:t>
             </a:r>
-            <a:endParaRPr lang="en-US"/>
           </a:p>
         </p:txBody>
       </p:sp>
@@ -883,7 +710,7 @@
           <a:p>
             <a:fld id="{5BCAD085-E8A6-8845-BD4E-CB4CCA059FC4}" type="datetimeFigureOut">
               <a:rPr lang="en-US" smtClean="0"/>
-              <a:t>1/27/13</a:t>
+              <a:t>7/28/2026</a:t>
             </a:fld>
             <a:endParaRPr lang="en-US"/>
           </a:p>
@@ -982,10 +809,9 @@
           <a:lstStyle/>
           <a:p>
             <a:r>
-              <a:rPr lang="en-US" smtClean="0"/>
+              <a:rPr lang="en-US"/>
               <a:t>Click to edit Master title style</a:t>
             </a:r>
-            <a:endParaRPr lang="en-US"/>
           </a:p>
         </p:txBody>
       </p:sp>
@@ -1011,38 +837,37 @@
           <a:p>
             <a:pPr lvl="0"/>
             <a:r>
-              <a:rPr lang="en-US" smtClean="0"/>
+              <a:rPr lang="en-US"/>
               <a:t>Click to edit Master text styles</a:t>
             </a:r>
           </a:p>
           <a:p>
             <a:pPr lvl="1"/>
             <a:r>
-              <a:rPr lang="en-US" smtClean="0"/>
+              <a:rPr lang="en-US"/>
               <a:t>Second level</a:t>
             </a:r>
           </a:p>
           <a:p>
             <a:pPr lvl="2"/>
             <a:r>
-              <a:rPr lang="en-US" smtClean="0"/>
+              <a:rPr lang="en-US"/>
               <a:t>Third level</a:t>
             </a:r>
           </a:p>
           <a:p>
             <a:pPr lvl="3"/>
             <a:r>
-              <a:rPr lang="en-US" smtClean="0"/>
+              <a:rPr lang="en-US"/>
               <a:t>Fourth level</a:t>
             </a:r>
           </a:p>
           <a:p>
             <a:pPr lvl="4"/>
             <a:r>
-              <a:rPr lang="en-US" smtClean="0"/>
+              <a:rPr lang="en-US"/>
               <a:t>Fifth level</a:t>
             </a:r>
-            <a:endParaRPr lang="en-US"/>
           </a:p>
         </p:txBody>
       </p:sp>
@@ -1063,7 +888,7 @@
           <a:p>
             <a:fld id="{5BCAD085-E8A6-8845-BD4E-CB4CCA059FC4}" type="datetimeFigureOut">
               <a:rPr lang="en-US" smtClean="0"/>
-              <a:t>1/27/13</a:t>
+              <a:t>7/28/2026</a:t>
             </a:fld>
             <a:endParaRPr lang="en-US"/>
           </a:p>
@@ -1157,10 +982,9 @@
           <a:lstStyle/>
           <a:p>
             <a:r>
-              <a:rPr lang="en-US" smtClean="0"/>
+              <a:rPr lang="en-US"/>
               <a:t>Click to edit Master title style</a:t>
             </a:r>
-            <a:endParaRPr lang="en-US"/>
           </a:p>
         </p:txBody>
       </p:sp>
@@ -1181,38 +1005,37 @@
           <a:p>
             <a:pPr lvl="0"/>
             <a:r>
-              <a:rPr lang="en-US" smtClean="0"/>
+              <a:rPr lang="en-US"/>
               <a:t>Click to edit Master text styles</a:t>
             </a:r>
           </a:p>
           <a:p>
             <a:pPr lvl="1"/>
             <a:r>
-              <a:rPr lang="en-US" smtClean="0"/>
+              <a:rPr lang="en-US"/>
               <a:t>Second level</a:t>
             </a:r>
           </a:p>
           <a:p>
             <a:pPr lvl="2"/>
             <a:r>
-              <a:rPr lang="en-US" smtClean="0"/>
+              <a:rPr lang="en-US"/>
               <a:t>Third level</a:t>
             </a:r>
           </a:p>
           <a:p>
             <a:pPr lvl="3"/>
             <a:r>
-              <a:rPr lang="en-US" smtClean="0"/>
+              <a:rPr lang="en-US"/>
               <a:t>Fourth level</a:t>
             </a:r>
           </a:p>
           <a:p>
             <a:pPr lvl="4"/>
             <a:r>
-              <a:rPr lang="en-US" smtClean="0"/>
+              <a:rPr lang="en-US"/>
               <a:t>Fifth level</a:t>
             </a:r>
-            <a:endParaRPr lang="en-US"/>
           </a:p>
         </p:txBody>
       </p:sp>
@@ -1233,7 +1056,7 @@
           <a:p>
             <a:fld id="{5BCAD085-E8A6-8845-BD4E-CB4CCA059FC4}" type="datetimeFigureOut">
               <a:rPr lang="en-US" smtClean="0"/>
-              <a:t>1/27/13</a:t>
+              <a:t>7/28/2026</a:t>
             </a:fld>
             <a:endParaRPr lang="en-US"/>
           </a:p>
@@ -1336,10 +1159,9 @@
           </a:lstStyle>
           <a:p>
             <a:r>
-              <a:rPr lang="en-US" smtClean="0"/>
+              <a:rPr lang="en-US"/>
               <a:t>Click to edit Master title style</a:t>
             </a:r>
-            <a:endParaRPr lang="en-US"/>
           </a:p>
         </p:txBody>
       </p:sp>
@@ -1456,7 +1278,7 @@
           <a:p>
             <a:pPr lvl="0"/>
             <a:r>
-              <a:rPr lang="en-US" smtClean="0"/>
+              <a:rPr lang="en-US"/>
               <a:t>Click to edit Master text styles</a:t>
             </a:r>
           </a:p>
@@ -1479,7 +1301,7 @@
           <a:p>
             <a:fld id="{5BCAD085-E8A6-8845-BD4E-CB4CCA059FC4}" type="datetimeFigureOut">
               <a:rPr lang="en-US" smtClean="0"/>
-              <a:t>1/27/13</a:t>
+              <a:t>7/28/2026</a:t>
             </a:fld>
             <a:endParaRPr lang="en-US"/>
           </a:p>
@@ -1573,10 +1395,9 @@
           <a:lstStyle/>
           <a:p>
             <a:r>
-              <a:rPr lang="en-US" smtClean="0"/>
+              <a:rPr lang="en-US"/>
               <a:t>Click to edit Master title style</a:t>
             </a:r>
-            <a:endParaRPr lang="en-US"/>
           </a:p>
         </p:txBody>
       </p:sp>
@@ -1630,38 +1451,37 @@
           <a:p>
             <a:pPr lvl="0"/>
             <a:r>
-              <a:rPr lang="en-US" smtClean="0"/>
+              <a:rPr lang="en-US"/>
               <a:t>Click to edit Master text styles</a:t>
             </a:r>
           </a:p>
           <a:p>
             <a:pPr lvl="1"/>
             <a:r>
-              <a:rPr lang="en-US" smtClean="0"/>
+              <a:rPr lang="en-US"/>
               <a:t>Second level</a:t>
             </a:r>
           </a:p>
           <a:p>
             <a:pPr lvl="2"/>
             <a:r>
-              <a:rPr lang="en-US" smtClean="0"/>
+              <a:rPr lang="en-US"/>
               <a:t>Third level</a:t>
             </a:r>
           </a:p>
           <a:p>
             <a:pPr lvl="3"/>
             <a:r>
-              <a:rPr lang="en-US" smtClean="0"/>
+              <a:rPr lang="en-US"/>
               <a:t>Fourth level</a:t>
             </a:r>
           </a:p>
           <a:p>
             <a:pPr lvl="4"/>
             <a:r>
-              <a:rPr lang="en-US" smtClean="0"/>
+              <a:rPr lang="en-US"/>
               <a:t>Fifth level</a:t>
             </a:r>
-            <a:endParaRPr lang="en-US"/>
           </a:p>
         </p:txBody>
       </p:sp>
@@ -1715,38 +1535,37 @@
           <a:p>
             <a:pPr lvl="0"/>
             <a:r>
-              <a:rPr lang="en-US" smtClean="0"/>
+              <a:rPr lang="en-US"/>
               <a:t>Click to edit Master text styles</a:t>
             </a:r>
           </a:p>
           <a:p>
             <a:pPr lvl="1"/>
             <a:r>
-              <a:rPr lang="en-US" smtClean="0"/>
+              <a:rPr lang="en-US"/>
               <a:t>Second level</a:t>
             </a:r>
           </a:p>
           <a:p>
             <a:pPr lvl="2"/>
             <a:r>
-              <a:rPr lang="en-US" smtClean="0"/>
+              <a:rPr lang="en-US"/>
               <a:t>Third level</a:t>
             </a:r>
           </a:p>
           <a:p>
             <a:pPr lvl="3"/>
             <a:r>
-              <a:rPr lang="en-US" smtClean="0"/>
+              <a:rPr lang="en-US"/>
               <a:t>Fourth level</a:t>
             </a:r>
           </a:p>
           <a:p>
             <a:pPr lvl="4"/>
             <a:r>
-              <a:rPr lang="en-US" smtClean="0"/>
+              <a:rPr lang="en-US"/>
               <a:t>Fifth level</a:t>
             </a:r>
-            <a:endParaRPr lang="en-US"/>
           </a:p>
         </p:txBody>
       </p:sp>
@@ -1767,7 +1586,7 @@
           <a:p>
             <a:fld id="{5BCAD085-E8A6-8845-BD4E-CB4CCA059FC4}" type="datetimeFigureOut">
               <a:rPr lang="en-US" smtClean="0"/>
-              <a:t>1/27/13</a:t>
+              <a:t>7/28/2026</a:t>
             </a:fld>
             <a:endParaRPr lang="en-US"/>
           </a:p>
@@ -1865,10 +1684,9 @@
           </a:lstStyle>
           <a:p>
             <a:r>
-              <a:rPr lang="en-US" smtClean="0"/>
+              <a:rPr lang="en-US"/>
               <a:t>Click to edit Master title style</a:t>
             </a:r>
-            <a:endParaRPr lang="en-US"/>
           </a:p>
         </p:txBody>
       </p:sp>
@@ -1931,7 +1749,7 @@
           <a:p>
             <a:pPr lvl="0"/>
             <a:r>
-              <a:rPr lang="en-US" smtClean="0"/>
+              <a:rPr lang="en-US"/>
               <a:t>Click to edit Master text styles</a:t>
             </a:r>
           </a:p>
@@ -1987,38 +1805,37 @@
           <a:p>
             <a:pPr lvl="0"/>
             <a:r>
-              <a:rPr lang="en-US" smtClean="0"/>
+              <a:rPr lang="en-US"/>
               <a:t>Click to edit Master text styles</a:t>
             </a:r>
           </a:p>
           <a:p>
             <a:pPr lvl="1"/>
             <a:r>
-              <a:rPr lang="en-US" smtClean="0"/>
+              <a:rPr lang="en-US"/>
               <a:t>Second level</a:t>
             </a:r>
           </a:p>
           <a:p>
             <a:pPr lvl="2"/>
             <a:r>
-              <a:rPr lang="en-US" smtClean="0"/>
+              <a:rPr lang="en-US"/>
               <a:t>Third level</a:t>
             </a:r>
           </a:p>
           <a:p>
             <a:pPr lvl="3"/>
             <a:r>
-              <a:rPr lang="en-US" smtClean="0"/>
+              <a:rPr lang="en-US"/>
               <a:t>Fourth level</a:t>
             </a:r>
           </a:p>
           <a:p>
             <a:pPr lvl="4"/>
             <a:r>
-              <a:rPr lang="en-US" smtClean="0"/>
+              <a:rPr lang="en-US"/>
               <a:t>Fifth level</a:t>
             </a:r>
-            <a:endParaRPr lang="en-US"/>
           </a:p>
         </p:txBody>
       </p:sp>
@@ -2081,7 +1898,7 @@
           <a:p>
             <a:pPr lvl="0"/>
             <a:r>
-              <a:rPr lang="en-US" smtClean="0"/>
+              <a:rPr lang="en-US"/>
               <a:t>Click to edit Master text styles</a:t>
             </a:r>
           </a:p>
@@ -2137,38 +1954,37 @@
           <a:p>
             <a:pPr lvl="0"/>
             <a:r>
-              <a:rPr lang="en-US" smtClean="0"/>
+              <a:rPr lang="en-US"/>
               <a:t>Click to edit Master text styles</a:t>
             </a:r>
           </a:p>
           <a:p>
             <a:pPr lvl="1"/>
             <a:r>
-              <a:rPr lang="en-US" smtClean="0"/>
+              <a:rPr lang="en-US"/>
               <a:t>Second level</a:t>
             </a:r>
           </a:p>
           <a:p>
             <a:pPr lvl="2"/>
             <a:r>
-              <a:rPr lang="en-US" smtClean="0"/>
+              <a:rPr lang="en-US"/>
               <a:t>Third level</a:t>
             </a:r>
           </a:p>
           <a:p>
             <a:pPr lvl="3"/>
             <a:r>
-              <a:rPr lang="en-US" smtClean="0"/>
+              <a:rPr lang="en-US"/>
               <a:t>Fourth level</a:t>
             </a:r>
           </a:p>
           <a:p>
             <a:pPr lvl="4"/>
             <a:r>
-              <a:rPr lang="en-US" smtClean="0"/>
+              <a:rPr lang="en-US"/>
               <a:t>Fifth level</a:t>
             </a:r>
-            <a:endParaRPr lang="en-US"/>
           </a:p>
         </p:txBody>
       </p:sp>
@@ -2189,7 +2005,7 @@
           <a:p>
             <a:fld id="{5BCAD085-E8A6-8845-BD4E-CB4CCA059FC4}" type="datetimeFigureOut">
               <a:rPr lang="en-US" smtClean="0"/>
-              <a:t>1/27/13</a:t>
+              <a:t>7/28/2026</a:t>
             </a:fld>
             <a:endParaRPr lang="en-US"/>
           </a:p>
@@ -2283,10 +2099,9 @@
           <a:lstStyle/>
           <a:p>
             <a:r>
-              <a:rPr lang="en-US" smtClean="0"/>
+              <a:rPr lang="en-US"/>
               <a:t>Click to edit Master title style</a:t>
             </a:r>
-            <a:endParaRPr lang="en-US"/>
           </a:p>
         </p:txBody>
       </p:sp>
@@ -2307,7 +2122,7 @@
           <a:p>
             <a:fld id="{5BCAD085-E8A6-8845-BD4E-CB4CCA059FC4}" type="datetimeFigureOut">
               <a:rPr lang="en-US" smtClean="0"/>
-              <a:t>1/27/13</a:t>
+              <a:t>7/28/2026</a:t>
             </a:fld>
             <a:endParaRPr lang="en-US"/>
           </a:p>
@@ -2402,7 +2217,7 @@
           <a:p>
             <a:fld id="{5BCAD085-E8A6-8845-BD4E-CB4CCA059FC4}" type="datetimeFigureOut">
               <a:rPr lang="en-US" smtClean="0"/>
-              <a:t>1/27/13</a:t>
+              <a:t>7/28/2026</a:t>
             </a:fld>
             <a:endParaRPr lang="en-US"/>
           </a:p>
@@ -2505,10 +2320,9 @@
           </a:lstStyle>
           <a:p>
             <a:r>
-              <a:rPr lang="en-US" smtClean="0"/>
+              <a:rPr lang="en-US"/>
               <a:t>Click to edit Master title style</a:t>
             </a:r>
-            <a:endParaRPr lang="en-US"/>
           </a:p>
         </p:txBody>
       </p:sp>
@@ -2562,38 +2376,37 @@
           <a:p>
             <a:pPr lvl="0"/>
             <a:r>
-              <a:rPr lang="en-US" smtClean="0"/>
+              <a:rPr lang="en-US"/>
               <a:t>Click to edit Master text styles</a:t>
             </a:r>
           </a:p>
           <a:p>
             <a:pPr lvl="1"/>
             <a:r>
-              <a:rPr lang="en-US" smtClean="0"/>
+              <a:rPr lang="en-US"/>
               <a:t>Second level</a:t>
             </a:r>
           </a:p>
           <a:p>
             <a:pPr lvl="2"/>
             <a:r>
-              <a:rPr lang="en-US" smtClean="0"/>
+              <a:rPr lang="en-US"/>
               <a:t>Third level</a:t>
             </a:r>
           </a:p>
           <a:p>
             <a:pPr lvl="3"/>
             <a:r>
-              <a:rPr lang="en-US" smtClean="0"/>
+              <a:rPr lang="en-US"/>
               <a:t>Fourth level</a:t>
             </a:r>
           </a:p>
           <a:p>
             <a:pPr lvl="4"/>
             <a:r>
-              <a:rPr lang="en-US" smtClean="0"/>
+              <a:rPr lang="en-US"/>
               <a:t>Fifth level</a:t>
             </a:r>
-            <a:endParaRPr lang="en-US"/>
           </a:p>
         </p:txBody>
       </p:sp>
@@ -2656,7 +2469,7 @@
           <a:p>
             <a:pPr lvl="0"/>
             <a:r>
-              <a:rPr lang="en-US" smtClean="0"/>
+              <a:rPr lang="en-US"/>
               <a:t>Click to edit Master text styles</a:t>
             </a:r>
           </a:p>
@@ -2679,7 +2492,7 @@
           <a:p>
             <a:fld id="{5BCAD085-E8A6-8845-BD4E-CB4CCA059FC4}" type="datetimeFigureOut">
               <a:rPr lang="en-US" smtClean="0"/>
-              <a:t>1/27/13</a:t>
+              <a:t>7/28/2026</a:t>
             </a:fld>
             <a:endParaRPr lang="en-US"/>
           </a:p>
@@ -2782,10 +2595,9 @@
           </a:lstStyle>
           <a:p>
             <a:r>
-              <a:rPr lang="en-US" smtClean="0"/>
+              <a:rPr lang="en-US"/>
               <a:t>Click to edit Master title style</a:t>
             </a:r>
-            <a:endParaRPr lang="en-US"/>
           </a:p>
         </p:txBody>
       </p:sp>
@@ -2909,7 +2721,7 @@
           <a:p>
             <a:pPr lvl="0"/>
             <a:r>
-              <a:rPr lang="en-US" smtClean="0"/>
+              <a:rPr lang="en-US"/>
               <a:t>Click to edit Master text styles</a:t>
             </a:r>
           </a:p>
@@ -2932,7 +2744,7 @@
           <a:p>
             <a:fld id="{5BCAD085-E8A6-8845-BD4E-CB4CCA059FC4}" type="datetimeFigureOut">
               <a:rPr lang="en-US" smtClean="0"/>
-              <a:t>1/27/13</a:t>
+              <a:t>7/28/2026</a:t>
             </a:fld>
             <a:endParaRPr lang="en-US"/>
           </a:p>
@@ -3041,10 +2853,9 @@
           <a:lstStyle/>
           <a:p>
             <a:r>
-              <a:rPr lang="en-US" smtClean="0"/>
+              <a:rPr lang="en-US"/>
               <a:t>Click to edit Master title style</a:t>
             </a:r>
-            <a:endParaRPr lang="en-US"/>
           </a:p>
         </p:txBody>
       </p:sp>
@@ -3075,38 +2886,37 @@
           <a:p>
             <a:pPr lvl="0"/>
             <a:r>
-              <a:rPr lang="en-US" smtClean="0"/>
+              <a:rPr lang="en-US"/>
               <a:t>Click to edit Master text styles</a:t>
             </a:r>
           </a:p>
           <a:p>
             <a:pPr lvl="1"/>
             <a:r>
-              <a:rPr lang="en-US" smtClean="0"/>
+              <a:rPr lang="en-US"/>
               <a:t>Second level</a:t>
             </a:r>
           </a:p>
           <a:p>
             <a:pPr lvl="2"/>
             <a:r>
-              <a:rPr lang="en-US" smtClean="0"/>
+              <a:rPr lang="en-US"/>
               <a:t>Third level</a:t>
             </a:r>
           </a:p>
           <a:p>
             <a:pPr lvl="3"/>
             <a:r>
-              <a:rPr lang="en-US" smtClean="0"/>
+              <a:rPr lang="en-US"/>
               <a:t>Fourth level</a:t>
             </a:r>
           </a:p>
           <a:p>
             <a:pPr lvl="4"/>
             <a:r>
-              <a:rPr lang="en-US" smtClean="0"/>
+              <a:rPr lang="en-US"/>
               <a:t>Fifth level</a:t>
             </a:r>
-            <a:endParaRPr lang="en-US"/>
           </a:p>
         </p:txBody>
       </p:sp>
@@ -3145,7 +2955,7 @@
           <a:p>
             <a:fld id="{5BCAD085-E8A6-8845-BD4E-CB4CCA059FC4}" type="datetimeFigureOut">
               <a:rPr lang="en-US" smtClean="0"/>
-              <a:t>1/27/13</a:t>
+              <a:t>7/28/2026</a:t>
             </a:fld>
             <a:endParaRPr lang="en-US"/>
           </a:p>
@@ -3504,7 +3314,7 @@
 </file>
 
 <file path=ppt/slides/slide1.xml><?xml version="1.0" encoding="utf-8"?>
-<p:sld xmlns:a="http://schemas.openxmlformats.org/drawingml/2006/main" xmlns:p="http://schemas.openxmlformats.org/presentationml/2006/main" xmlns:r="http://schemas.openxmlformats.org/officeDocument/2006/relationships">
+<p:sld xmlns:a="http://schemas.openxmlformats.org/drawingml/2006/main" xmlns:r="http://schemas.openxmlformats.org/officeDocument/2006/relationships" xmlns:p="http://schemas.openxmlformats.org/presentationml/2006/main">
   <p:cSld>
     <p:spTree>
       <p:nvGrpSpPr>
@@ -3512,7 +3322,14 @@
         <p:cNvGrpSpPr/>
         <p:nvPr/>
       </p:nvGrpSpPr>
-      <p:grpSpPr/>
+      <p:grpSpPr>
+        <a:xfrm>
+          <a:off x="0" y="0"/>
+          <a:ext cx="0" cy="0"/>
+          <a:chOff x="0" y="0"/>
+          <a:chExt cx="0" cy="0"/>
+        </a:xfrm>
+      </p:grpSpPr>
       <p:sp>
         <p:nvSpPr>
           <p:cNvPr id="2" name="TextBox 1"/>
@@ -3522,7 +3339,7 @@
         <p:spPr>
           <a:xfrm>
             <a:off x="685800" y="1371600"/>
-            <a:ext cx="10820095" cy="2011680"/>
+            <a:ext cx="10820095" cy="1123384"/>
           </a:xfrm>
           <a:prstGeom prst="rect">
             <a:avLst/>
@@ -3536,7 +3353,7 @@
           <a:lstStyle/>
           <a:p>
             <a:r>
-              <a:rPr sz="4000" b="1" i="0">
+              <a:rPr sz="4000" b="1" i="0" dirty="0">
                 <a:solidFill>
                   <a:srgbClr val="1A1A1A"/>
                 </a:solidFill>
@@ -3552,14 +3369,29 @@
               </a:spcBef>
             </a:pPr>
             <a:r>
-              <a:rPr sz="1700" b="0" i="0">
+              <a:rPr sz="1700" b="0" i="0" dirty="0">
                 <a:solidFill>
                   <a:srgbClr val="5A6270"/>
                 </a:solidFill>
                 <a:latin typeface="Calibri"/>
               </a:rPr>
-              <a:t>Executive summary. You asked three questions. Here are the three answers.</a:t>
-            </a:r>
+              <a:t>Executive summary</a:t>
+            </a:r>
+            <a:r>
+              <a:rPr lang="en-US" sz="1700" dirty="0">
+                <a:solidFill>
+                  <a:srgbClr val="5A6270"/>
+                </a:solidFill>
+                <a:latin typeface="Calibri"/>
+              </a:rPr>
+              <a:t>:</a:t>
+            </a:r>
+            <a:endParaRPr sz="1700" b="0" i="0" dirty="0">
+              <a:solidFill>
+                <a:srgbClr val="5A6270"/>
+              </a:solidFill>
+              <a:latin typeface="Calibri"/>
+            </a:endParaRPr>
           </a:p>
         </p:txBody>
       </p:sp>
@@ -3572,7 +3404,7 @@
         <p:spPr>
           <a:xfrm>
             <a:off x="685800" y="3200400"/>
-            <a:ext cx="10820095" cy="4572000"/>
+            <a:ext cx="10820095" cy="2141612"/>
           </a:xfrm>
           <a:prstGeom prst="rect">
             <a:avLst/>
@@ -3591,7 +3423,7 @@
               </a:spcAft>
             </a:pPr>
             <a:r>
-              <a:rPr sz="1600" b="1" i="0">
+              <a:rPr sz="1600" b="1" i="0" dirty="0">
                 <a:solidFill>
                   <a:srgbClr val="1A1A1A"/>
                 </a:solidFill>
@@ -3607,7 +3439,7 @@
               </a:spcAft>
             </a:pPr>
             <a:r>
-              <a:rPr sz="1400" b="0" i="0">
+              <a:rPr sz="1400" b="0" i="0" dirty="0">
                 <a:solidFill>
                   <a:srgbClr val="1A1A1A"/>
                 </a:solidFill>
@@ -3623,7 +3455,7 @@
               </a:spcAft>
             </a:pPr>
             <a:r>
-              <a:rPr sz="1600" b="1" i="0">
+              <a:rPr sz="1600" b="1" i="0" dirty="0">
                 <a:solidFill>
                   <a:srgbClr val="1A1A1A"/>
                 </a:solidFill>
@@ -3639,7 +3471,7 @@
               </a:spcAft>
             </a:pPr>
             <a:r>
-              <a:rPr sz="1400" b="0" i="0">
+              <a:rPr sz="1400" b="0" i="0" dirty="0">
                 <a:solidFill>
                   <a:srgbClr val="B02E2E"/>
                 </a:solidFill>
@@ -3655,7 +3487,7 @@
               </a:spcAft>
             </a:pPr>
             <a:r>
-              <a:rPr sz="1600" b="1" i="0">
+              <a:rPr sz="1600" b="1" i="0" dirty="0">
                 <a:solidFill>
                   <a:srgbClr val="1A1A1A"/>
                 </a:solidFill>
@@ -3671,13 +3503,40 @@
               </a:spcAft>
             </a:pPr>
             <a:r>
-              <a:rPr sz="1400" b="0" i="0">
+              <a:rPr lang="en-US" sz="1400" b="0" i="0" dirty="0">
                 <a:solidFill>
                   <a:srgbClr val="1E7A4B"/>
                 </a:solidFill>
                 <a:latin typeface="Calibri"/>
               </a:rPr>
-              <a:t>Calling every at-risk customer already pays for itself today. Beyond that we cannot yet prove what works, because we have never recorded taking an action.</a:t>
+              <a:t>Contacting</a:t>
+            </a:r>
+            <a:r>
+              <a:rPr sz="1400" b="0" i="0" dirty="0">
+                <a:solidFill>
+                  <a:srgbClr val="1E7A4B"/>
+                </a:solidFill>
+                <a:latin typeface="Calibri"/>
+              </a:rPr>
+              <a:t> every at-risk customer</a:t>
+            </a:r>
+            <a:r>
+              <a:rPr lang="en-US" sz="1400" b="0" i="0" dirty="0">
+                <a:solidFill>
+                  <a:srgbClr val="1E7A4B"/>
+                </a:solidFill>
+                <a:latin typeface="Calibri"/>
+              </a:rPr>
+              <a:t> as intervention</a:t>
+            </a:r>
+            <a:r>
+              <a:rPr sz="1400" b="0" i="0" dirty="0">
+                <a:solidFill>
+                  <a:srgbClr val="1E7A4B"/>
+                </a:solidFill>
+                <a:latin typeface="Calibri"/>
+              </a:rPr>
+              <a:t> already pays for itself today. Beyond that we cannot yet prove what works, because we have never recorded taking an action.</a:t>
             </a:r>
           </a:p>
         </p:txBody>
@@ -3691,7 +3550,7 @@
 </file>
 
 <file path=ppt/slides/slide2.xml><?xml version="1.0" encoding="utf-8"?>
-<p:sld xmlns:a="http://schemas.openxmlformats.org/drawingml/2006/main" xmlns:p="http://schemas.openxmlformats.org/presentationml/2006/main" xmlns:r="http://schemas.openxmlformats.org/officeDocument/2006/relationships">
+<p:sld xmlns:a="http://schemas.openxmlformats.org/drawingml/2006/main" xmlns:r="http://schemas.openxmlformats.org/officeDocument/2006/relationships" xmlns:p="http://schemas.openxmlformats.org/presentationml/2006/main">
   <p:cSld>
     <p:spTree>
       <p:nvGrpSpPr>
@@ -3699,7 +3558,14 @@
         <p:cNvGrpSpPr/>
         <p:nvPr/>
       </p:nvGrpSpPr>
-      <p:grpSpPr/>
+      <p:grpSpPr>
+        <a:xfrm>
+          <a:off x="0" y="0"/>
+          <a:ext cx="0" cy="0"/>
+          <a:chOff x="0" y="0"/>
+          <a:chExt cx="0" cy="0"/>
+        </a:xfrm>
+      </p:grpSpPr>
       <p:sp>
         <p:nvSpPr>
           <p:cNvPr id="2" name="TextBox 1"/>
@@ -3791,6 +3657,7 @@
           <a:lstStyle/>
           <a:p>
             <a:pPr algn="ctr"/>
+            <a:endParaRPr/>
           </a:p>
         </p:txBody>
       </p:sp>
@@ -3932,7 +3799,7 @@
 </file>
 
 <file path=ppt/slides/slide3.xml><?xml version="1.0" encoding="utf-8"?>
-<p:sld xmlns:a="http://schemas.openxmlformats.org/drawingml/2006/main" xmlns:p="http://schemas.openxmlformats.org/presentationml/2006/main" xmlns:r="http://schemas.openxmlformats.org/officeDocument/2006/relationships">
+<p:sld xmlns:a="http://schemas.openxmlformats.org/drawingml/2006/main" xmlns:r="http://schemas.openxmlformats.org/officeDocument/2006/relationships" xmlns:p="http://schemas.openxmlformats.org/presentationml/2006/main">
   <p:cSld>
     <p:spTree>
       <p:nvGrpSpPr>
@@ -3940,7 +3807,14 @@
         <p:cNvGrpSpPr/>
         <p:nvPr/>
       </p:nvGrpSpPr>
-      <p:grpSpPr/>
+      <p:grpSpPr>
+        <a:xfrm>
+          <a:off x="0" y="0"/>
+          <a:ext cx="0" cy="0"/>
+          <a:chOff x="0" y="0"/>
+          <a:chExt cx="0" cy="0"/>
+        </a:xfrm>
+      </p:grpSpPr>
       <p:sp>
         <p:nvSpPr>
           <p:cNvPr id="2" name="TextBox 1"/>
@@ -4032,6 +3906,7 @@
           <a:lstStyle/>
           <a:p>
             <a:pPr algn="ctr"/>
+            <a:endParaRPr/>
           </a:p>
         </p:txBody>
       </p:sp>
@@ -4277,7 +4152,7 @@
 </file>
 
 <file path=ppt/slides/slide4.xml><?xml version="1.0" encoding="utf-8"?>
-<p:sld xmlns:a="http://schemas.openxmlformats.org/drawingml/2006/main" xmlns:p="http://schemas.openxmlformats.org/presentationml/2006/main" xmlns:r="http://schemas.openxmlformats.org/officeDocument/2006/relationships">
+<p:sld xmlns:a="http://schemas.openxmlformats.org/drawingml/2006/main" xmlns:r="http://schemas.openxmlformats.org/officeDocument/2006/relationships" xmlns:p="http://schemas.openxmlformats.org/presentationml/2006/main">
   <p:cSld>
     <p:spTree>
       <p:nvGrpSpPr>
@@ -4285,7 +4160,14 @@
         <p:cNvGrpSpPr/>
         <p:nvPr/>
       </p:nvGrpSpPr>
-      <p:grpSpPr/>
+      <p:grpSpPr>
+        <a:xfrm>
+          <a:off x="0" y="0"/>
+          <a:ext cx="0" cy="0"/>
+          <a:chOff x="0" y="0"/>
+          <a:chExt cx="0" cy="0"/>
+        </a:xfrm>
+      </p:grpSpPr>
       <p:sp>
         <p:nvSpPr>
           <p:cNvPr id="2" name="TextBox 1"/>
@@ -4377,6 +4259,7 @@
           <a:lstStyle/>
           <a:p>
             <a:pPr algn="ctr"/>
+            <a:endParaRPr/>
           </a:p>
         </p:txBody>
       </p:sp>
@@ -4624,7 +4507,7 @@
 </file>
 
 <file path=ppt/slides/slide5.xml><?xml version="1.0" encoding="utf-8"?>
-<p:sld xmlns:a="http://schemas.openxmlformats.org/drawingml/2006/main" xmlns:p="http://schemas.openxmlformats.org/presentationml/2006/main" xmlns:r="http://schemas.openxmlformats.org/officeDocument/2006/relationships">
+<p:sld xmlns:a="http://schemas.openxmlformats.org/drawingml/2006/main" xmlns:r="http://schemas.openxmlformats.org/officeDocument/2006/relationships" xmlns:p="http://schemas.openxmlformats.org/presentationml/2006/main">
   <p:cSld>
     <p:spTree>
       <p:nvGrpSpPr>
@@ -4632,7 +4515,14 @@
         <p:cNvGrpSpPr/>
         <p:nvPr/>
       </p:nvGrpSpPr>
-      <p:grpSpPr/>
+      <p:grpSpPr>
+        <a:xfrm>
+          <a:off x="0" y="0"/>
+          <a:ext cx="0" cy="0"/>
+          <a:chOff x="0" y="0"/>
+          <a:chExt cx="0" cy="0"/>
+        </a:xfrm>
+      </p:grpSpPr>
       <p:sp>
         <p:nvSpPr>
           <p:cNvPr id="2" name="TextBox 1"/>
@@ -4724,6 +4614,7 @@
           <a:lstStyle/>
           <a:p>
             <a:pPr algn="ctr"/>
+            <a:endParaRPr/>
           </a:p>
         </p:txBody>
       </p:sp>
@@ -5109,7 +5000,7 @@
 </file>
 
 <file path=ppt/slides/slide6.xml><?xml version="1.0" encoding="utf-8"?>
-<p:sld xmlns:a="http://schemas.openxmlformats.org/drawingml/2006/main" xmlns:p="http://schemas.openxmlformats.org/presentationml/2006/main" xmlns:r="http://schemas.openxmlformats.org/officeDocument/2006/relationships">
+<p:sld xmlns:a="http://schemas.openxmlformats.org/drawingml/2006/main" xmlns:r="http://schemas.openxmlformats.org/officeDocument/2006/relationships" xmlns:p="http://schemas.openxmlformats.org/presentationml/2006/main">
   <p:cSld>
     <p:spTree>
       <p:nvGrpSpPr>
@@ -5117,7 +5008,14 @@
         <p:cNvGrpSpPr/>
         <p:nvPr/>
       </p:nvGrpSpPr>
-      <p:grpSpPr/>
+      <p:grpSpPr>
+        <a:xfrm>
+          <a:off x="0" y="0"/>
+          <a:ext cx="0" cy="0"/>
+          <a:chOff x="0" y="0"/>
+          <a:chExt cx="0" cy="0"/>
+        </a:xfrm>
+      </p:grpSpPr>
       <p:sp>
         <p:nvSpPr>
           <p:cNvPr id="2" name="TextBox 1"/>
@@ -5209,6 +5107,7 @@
           <a:lstStyle/>
           <a:p>
             <a:pPr algn="ctr"/>
+            <a:endParaRPr/>
           </a:p>
         </p:txBody>
       </p:sp>
@@ -5784,44 +5683,44 @@
         <a:sysClr val="window" lastClr="FFFFFF"/>
       </a:lt1>
       <a:dk2>
-        <a:srgbClr val="1F497D"/>
+        <a:srgbClr val="0E2841"/>
       </a:dk2>
       <a:lt2>
-        <a:srgbClr val="EEECE1"/>
+        <a:srgbClr val="E8E8E8"/>
       </a:lt2>
       <a:accent1>
-        <a:srgbClr val="4F81BD"/>
+        <a:srgbClr val="156082"/>
       </a:accent1>
       <a:accent2>
-        <a:srgbClr val="C0504D"/>
+        <a:srgbClr val="E97132"/>
       </a:accent2>
       <a:accent3>
-        <a:srgbClr val="9BBB59"/>
+        <a:srgbClr val="196B24"/>
       </a:accent3>
       <a:accent4>
-        <a:srgbClr val="8064A2"/>
+        <a:srgbClr val="0F9ED5"/>
       </a:accent4>
       <a:accent5>
-        <a:srgbClr val="4BACC6"/>
+        <a:srgbClr val="A02B93"/>
       </a:accent5>
       <a:accent6>
-        <a:srgbClr val="F79646"/>
+        <a:srgbClr val="4EA72E"/>
       </a:accent6>
       <a:hlink>
-        <a:srgbClr val="0000FF"/>
+        <a:srgbClr val="467886"/>
       </a:hlink>
       <a:folHlink>
-        <a:srgbClr val="800080"/>
+        <a:srgbClr val="96607D"/>
       </a:folHlink>
     </a:clrScheme>
     <a:fontScheme name="Office">
       <a:majorFont>
-        <a:latin typeface="Calibri"/>
+        <a:latin typeface="Aptos Display" panose="02110004020202020204"/>
         <a:ea typeface=""/>
         <a:cs typeface=""/>
-        <a:font script="Jpan" typeface="ＭＳ Ｐゴシック"/>
+        <a:font script="Jpan" typeface="游ゴシック Light"/>
         <a:font script="Hang" typeface="맑은 고딕"/>
-        <a:font script="Hans" typeface="宋体"/>
+        <a:font script="Hans" typeface="等线 Light"/>
         <a:font script="Hant" typeface="新細明體"/>
         <a:font script="Arab" typeface="Times New Roman"/>
         <a:font script="Hebr" typeface="Times New Roman"/>
@@ -5849,14 +5748,31 @@
         <a:font script="Viet" typeface="Times New Roman"/>
         <a:font script="Uigh" typeface="Microsoft Uighur"/>
         <a:font script="Geor" typeface="Sylfaen"/>
+        <a:font script="Armn" typeface="Arial"/>
+        <a:font script="Bugi" typeface="Leelawadee UI"/>
+        <a:font script="Bopo" typeface="Microsoft JhengHei"/>
+        <a:font script="Java" typeface="Javanese Text"/>
+        <a:font script="Lisu" typeface="Segoe UI"/>
+        <a:font script="Mymr" typeface="Myanmar Text"/>
+        <a:font script="Nkoo" typeface="Ebrima"/>
+        <a:font script="Olck" typeface="Nirmala UI"/>
+        <a:font script="Osma" typeface="Ebrima"/>
+        <a:font script="Phag" typeface="Phagspa"/>
+        <a:font script="Syrn" typeface="Estrangelo Edessa"/>
+        <a:font script="Syrj" typeface="Estrangelo Edessa"/>
+        <a:font script="Syre" typeface="Estrangelo Edessa"/>
+        <a:font script="Sora" typeface="Nirmala UI"/>
+        <a:font script="Tale" typeface="Microsoft Tai Le"/>
+        <a:font script="Talu" typeface="Microsoft New Tai Lue"/>
+        <a:font script="Tfng" typeface="Ebrima"/>
       </a:majorFont>
       <a:minorFont>
-        <a:latin typeface="Calibri"/>
+        <a:latin typeface="Aptos" panose="02110004020202020204"/>
         <a:ea typeface=""/>
         <a:cs typeface=""/>
-        <a:font script="Jpan" typeface="ＭＳ Ｐゴシック"/>
+        <a:font script="Jpan" typeface="游ゴシック"/>
         <a:font script="Hang" typeface="맑은 고딕"/>
-        <a:font script="Hans" typeface="宋体"/>
+        <a:font script="Hans" typeface="等线"/>
         <a:font script="Hant" typeface="新細明體"/>
         <a:font script="Arab" typeface="Arial"/>
         <a:font script="Hebr" typeface="Arial"/>
@@ -5884,6 +5800,23 @@
         <a:font script="Viet" typeface="Arial"/>
         <a:font script="Uigh" typeface="Microsoft Uighur"/>
         <a:font script="Geor" typeface="Sylfaen"/>
+        <a:font script="Armn" typeface="Arial"/>
+        <a:font script="Bugi" typeface="Leelawadee UI"/>
+        <a:font script="Bopo" typeface="Microsoft JhengHei"/>
+        <a:font script="Java" typeface="Javanese Text"/>
+        <a:font script="Lisu" typeface="Segoe UI"/>
+        <a:font script="Mymr" typeface="Myanmar Text"/>
+        <a:font script="Nkoo" typeface="Ebrima"/>
+        <a:font script="Olck" typeface="Nirmala UI"/>
+        <a:font script="Osma" typeface="Ebrima"/>
+        <a:font script="Phag" typeface="Phagspa"/>
+        <a:font script="Syrn" typeface="Estrangelo Edessa"/>
+        <a:font script="Syrj" typeface="Estrangelo Edessa"/>
+        <a:font script="Syre" typeface="Estrangelo Edessa"/>
+        <a:font script="Sora" typeface="Nirmala UI"/>
+        <a:font script="Tale" typeface="Microsoft Tai Le"/>
+        <a:font script="Talu" typeface="Microsoft New Tai Lue"/>
+        <a:font script="Tfng" typeface="Ebrima"/>
       </a:minorFont>
     </a:fontScheme>
     <a:fmtScheme name="Office">
@@ -5895,180 +5828,136 @@
           <a:gsLst>
             <a:gs pos="0">
               <a:schemeClr val="phClr">
-                <a:tint val="50000"/>
-                <a:satMod val="300000"/>
+                <a:lumMod val="110000"/>
+                <a:satMod val="105000"/>
+                <a:tint val="67000"/>
               </a:schemeClr>
             </a:gs>
-            <a:gs pos="35000">
+            <a:gs pos="50000">
               <a:schemeClr val="phClr">
-                <a:tint val="37000"/>
-                <a:satMod val="300000"/>
+                <a:lumMod val="105000"/>
+                <a:satMod val="103000"/>
+                <a:tint val="73000"/>
               </a:schemeClr>
             </a:gs>
             <a:gs pos="100000">
               <a:schemeClr val="phClr">
-                <a:tint val="15000"/>
-                <a:satMod val="350000"/>
+                <a:lumMod val="105000"/>
+                <a:satMod val="109000"/>
+                <a:tint val="81000"/>
               </a:schemeClr>
             </a:gs>
           </a:gsLst>
-          <a:lin ang="16200000" scaled="1"/>
+          <a:lin ang="5400000" scaled="0"/>
         </a:gradFill>
         <a:gradFill rotWithShape="1">
           <a:gsLst>
             <a:gs pos="0">
               <a:schemeClr val="phClr">
-                <a:tint val="100000"/>
+                <a:satMod val="103000"/>
+                <a:lumMod val="102000"/>
+                <a:tint val="94000"/>
+              </a:schemeClr>
+            </a:gs>
+            <a:gs pos="50000">
+              <a:schemeClr val="phClr">
+                <a:satMod val="110000"/>
+                <a:lumMod val="100000"/>
                 <a:shade val="100000"/>
-                <a:satMod val="130000"/>
               </a:schemeClr>
             </a:gs>
             <a:gs pos="100000">
               <a:schemeClr val="phClr">
-                <a:tint val="50000"/>
-                <a:shade val="100000"/>
-                <a:satMod val="350000"/>
+                <a:lumMod val="99000"/>
+                <a:satMod val="120000"/>
+                <a:shade val="78000"/>
               </a:schemeClr>
             </a:gs>
           </a:gsLst>
-          <a:lin ang="16200000" scaled="0"/>
+          <a:lin ang="5400000" scaled="0"/>
         </a:gradFill>
       </a:fillStyleLst>
       <a:lnStyleLst>
-        <a:ln w="9525" cap="flat" cmpd="sng" algn="ctr">
+        <a:ln w="12700" cap="flat" cmpd="sng" algn="ctr">
           <a:solidFill>
-            <a:schemeClr val="phClr">
-              <a:shade val="95000"/>
-              <a:satMod val="105000"/>
-            </a:schemeClr>
+            <a:schemeClr val="phClr"/>
           </a:solidFill>
           <a:prstDash val="solid"/>
+          <a:miter lim="800000"/>
+        </a:ln>
+        <a:ln w="19050" cap="flat" cmpd="sng" algn="ctr">
+          <a:solidFill>
+            <a:schemeClr val="phClr"/>
+          </a:solidFill>
+          <a:prstDash val="solid"/>
+          <a:miter lim="800000"/>
         </a:ln>
         <a:ln w="25400" cap="flat" cmpd="sng" algn="ctr">
           <a:solidFill>
             <a:schemeClr val="phClr"/>
           </a:solidFill>
           <a:prstDash val="solid"/>
-        </a:ln>
-        <a:ln w="38100" cap="flat" cmpd="sng" algn="ctr">
-          <a:solidFill>
-            <a:schemeClr val="phClr"/>
-          </a:solidFill>
-          <a:prstDash val="solid"/>
+          <a:miter lim="800000"/>
         </a:ln>
       </a:lnStyleLst>
       <a:effectStyleLst>
         <a:effectStyle>
+          <a:effectLst/>
+        </a:effectStyle>
+        <a:effectStyle>
+          <a:effectLst/>
+        </a:effectStyle>
+        <a:effectStyle>
           <a:effectLst>
-            <a:outerShdw blurRad="40000" dist="20000" dir="5400000" rotWithShape="0">
+            <a:outerShdw blurRad="57150" dist="19050" dir="5400000" algn="ctr" rotWithShape="0">
               <a:srgbClr val="000000">
-                <a:alpha val="38000"/>
+                <a:alpha val="63000"/>
               </a:srgbClr>
             </a:outerShdw>
           </a:effectLst>
-        </a:effectStyle>
-        <a:effectStyle>
-          <a:effectLst>
-            <a:outerShdw blurRad="40000" dist="23000" dir="5400000" rotWithShape="0">
-              <a:srgbClr val="000000">
-                <a:alpha val="35000"/>
-              </a:srgbClr>
-            </a:outerShdw>
-          </a:effectLst>
-        </a:effectStyle>
-        <a:effectStyle>
-          <a:effectLst>
-            <a:outerShdw blurRad="40000" dist="23000" dir="5400000" rotWithShape="0">
-              <a:srgbClr val="000000">
-                <a:alpha val="35000"/>
-              </a:srgbClr>
-            </a:outerShdw>
-          </a:effectLst>
-          <a:scene3d>
-            <a:camera prst="orthographicFront">
-              <a:rot lat="0" lon="0" rev="0"/>
-            </a:camera>
-            <a:lightRig rig="threePt" dir="t">
-              <a:rot lat="0" lon="0" rev="1200000"/>
-            </a:lightRig>
-          </a:scene3d>
-          <a:sp3d>
-            <a:bevelT w="63500" h="25400"/>
-          </a:sp3d>
         </a:effectStyle>
       </a:effectStyleLst>
       <a:bgFillStyleLst>
         <a:solidFill>
           <a:schemeClr val="phClr"/>
         </a:solidFill>
+        <a:solidFill>
+          <a:schemeClr val="phClr">
+            <a:tint val="95000"/>
+            <a:satMod val="170000"/>
+          </a:schemeClr>
+        </a:solidFill>
         <a:gradFill rotWithShape="1">
           <a:gsLst>
             <a:gs pos="0">
               <a:schemeClr val="phClr">
-                <a:tint val="40000"/>
-                <a:satMod val="350000"/>
+                <a:tint val="93000"/>
+                <a:satMod val="150000"/>
+                <a:shade val="98000"/>
+                <a:lumMod val="102000"/>
               </a:schemeClr>
             </a:gs>
-            <a:gs pos="40000">
+            <a:gs pos="50000">
               <a:schemeClr val="phClr">
-                <a:tint val="45000"/>
-                <a:shade val="99000"/>
-                <a:satMod val="350000"/>
+                <a:tint val="98000"/>
+                <a:satMod val="130000"/>
+                <a:shade val="90000"/>
+                <a:lumMod val="103000"/>
               </a:schemeClr>
             </a:gs>
             <a:gs pos="100000">
               <a:schemeClr val="phClr">
-                <a:shade val="20000"/>
-                <a:satMod val="255000"/>
+                <a:shade val="63000"/>
+                <a:satMod val="120000"/>
               </a:schemeClr>
             </a:gs>
           </a:gsLst>
-          <a:path path="circle">
-            <a:fillToRect l="50000" t="-80000" r="50000" b="180000"/>
-          </a:path>
-        </a:gradFill>
-        <a:gradFill rotWithShape="1">
-          <a:gsLst>
-            <a:gs pos="0">
-              <a:schemeClr val="phClr">
-                <a:tint val="80000"/>
-                <a:satMod val="300000"/>
-              </a:schemeClr>
-            </a:gs>
-            <a:gs pos="100000">
-              <a:schemeClr val="phClr">
-                <a:shade val="30000"/>
-                <a:satMod val="200000"/>
-              </a:schemeClr>
-            </a:gs>
-          </a:gsLst>
-          <a:path path="circle">
-            <a:fillToRect l="50000" t="50000" r="50000" b="50000"/>
-          </a:path>
+          <a:lin ang="5400000" scaled="0"/>
         </a:gradFill>
       </a:bgFillStyleLst>
     </a:fmtScheme>
   </a:themeElements>
   <a:objectDefaults>
-    <a:spDef>
-      <a:spPr/>
-      <a:bodyPr/>
-      <a:lstStyle/>
-      <a:style>
-        <a:lnRef idx="1">
-          <a:schemeClr val="accent1"/>
-        </a:lnRef>
-        <a:fillRef idx="3">
-          <a:schemeClr val="accent1"/>
-        </a:fillRef>
-        <a:effectRef idx="2">
-          <a:schemeClr val="accent1"/>
-        </a:effectRef>
-        <a:fontRef idx="minor">
-          <a:schemeClr val="lt1"/>
-        </a:fontRef>
-      </a:style>
-    </a:spDef>
     <a:lnDef>
       <a:spPr/>
       <a:bodyPr/>
@@ -6090,5 +5979,10 @@
     </a:lnDef>
   </a:objectDefaults>
   <a:extraClrSchemeLst/>
+  <a:extLst>
+    <a:ext uri="{05A4C25C-085E-4340-85A3-A5531E510DB2}">
+      <thm15:themeFamily xmlns:thm15="http://schemas.microsoft.com/office/thememl/2012/main" name="Office Theme" id="{2E142A2C-CD16-42D6-873A-C26D2A0506FA}" vid="{1BDDFF52-6CD6-40A5-AB3C-68EB2F1E4D0A}"/>
+    </a:ext>
+  </a:extLst>
 </a:theme>
 </file>
</xml_diff>

<commit_message>
Make the deck build path portable and credit the dataset author
deck_style.py hardcoded an absolute path to one machine's figures directory,
which breaks for anyone else and leaks a local folder structure. Resolve it
relative to the file instead, matching the idiom already used for the output
path in build_main_deck.py.

Also name River @ Rivalytics explicitly in the README. The RavenStack dataset
is MIT-like, but its licence requires crediting the author and a bare mention
of Kaggle/Rivalytics did not.

Co-Authored-By: Claude Opus 5 (1M context) <noreply@anthropic.com>
</commit_message>
<xml_diff>
--- a/outputs/AvePoint_Executive_Summary.pptx
+++ b/outputs/AvePoint_Executive_Summary.pptx
@@ -4,18 +4,15 @@
   <p:sldMasterIdLst>
     <p:sldMasterId id="2147483648" r:id="rId1"/>
   </p:sldMasterIdLst>
-  <p:notesMasterIdLst>
-    <p:notesMasterId r:id="rId8"/>
-  </p:notesMasterIdLst>
   <p:sldIdLst>
-    <p:sldId id="256" r:id="rId2"/>
-    <p:sldId id="257" r:id="rId3"/>
-    <p:sldId id="258" r:id="rId4"/>
-    <p:sldId id="259" r:id="rId5"/>
-    <p:sldId id="260" r:id="rId6"/>
-    <p:sldId id="261" r:id="rId7"/>
+    <p:sldId id="256" r:id="rId7"/>
+    <p:sldId id="257" r:id="rId9"/>
+    <p:sldId id="258" r:id="rId10"/>
+    <p:sldId id="259" r:id="rId11"/>
+    <p:sldId id="260" r:id="rId12"/>
+    <p:sldId id="261" r:id="rId13"/>
   </p:sldIdLst>
-  <p:sldSz cx="12192000" cy="6858000"/>
+  <p:sldSz cx="12191695" cy="6858000" type="screen4x3"/>
   <p:notesSz cx="6858000" cy="9144000"/>
   <p:defaultTextStyle>
     <a:defPPr>
@@ -112,64 +109,11 @@
       </a:defRPr>
     </a:lvl9pPr>
   </p:defaultTextStyle>
-  <p:extLst>
-    <p:ext uri="{EFAFB233-063F-42B5-8137-9DF3F51BA10A}">
-      <p15:sldGuideLst xmlns:p15="http://schemas.microsoft.com/office/powerpoint/2012/main">
-        <p15:guide id="1" orient="horz" pos="2160">
-          <p15:clr>
-            <a:srgbClr val="A4A3A4"/>
-          </p15:clr>
-        </p15:guide>
-        <p15:guide id="2" pos="2880">
-          <p15:clr>
-            <a:srgbClr val="A4A3A4"/>
-          </p15:clr>
-        </p15:guide>
-      </p15:sldGuideLst>
-    </p:ext>
-  </p:extLst>
 </p:presentation>
 </file>
 
-<file path=ppt/changesInfos/changesInfo1.xml><?xml version="1.0" encoding="utf-8"?>
-<pc:chgInfo xmlns:a="http://schemas.openxmlformats.org/drawingml/2006/main" xmlns:r="http://schemas.openxmlformats.org/officeDocument/2006/relationships" xmlns:ac="http://schemas.microsoft.com/office/drawing/2013/main/command" xmlns:pc="http://schemas.microsoft.com/office/powerpoint/2013/main/command">
-  <pc:docChgLst>
-    <pc:chgData name="Dmitriy Ratushny" userId="08050032e8047aee" providerId="LiveId" clId="{78EB1A6D-D3A9-4525-A4D5-A50D4E20D487}"/>
-    <pc:docChg chg="modSld">
-      <pc:chgData name="Dmitriy Ratushny" userId="08050032e8047aee" providerId="LiveId" clId="{78EB1A6D-D3A9-4525-A4D5-A50D4E20D487}" dt="2026-07-28T17:18:55.324" v="31" actId="20577"/>
-      <pc:docMkLst>
-        <pc:docMk/>
-      </pc:docMkLst>
-      <pc:sldChg chg="modSp mod">
-        <pc:chgData name="Dmitriy Ratushny" userId="08050032e8047aee" providerId="LiveId" clId="{78EB1A6D-D3A9-4525-A4D5-A50D4E20D487}" dt="2026-07-28T17:18:55.324" v="31" actId="20577"/>
-        <pc:sldMkLst>
-          <pc:docMk/>
-          <pc:sldMk cId="0" sldId="256"/>
-        </pc:sldMkLst>
-        <pc:spChg chg="mod">
-          <ac:chgData name="Dmitriy Ratushny" userId="08050032e8047aee" providerId="LiveId" clId="{78EB1A6D-D3A9-4525-A4D5-A50D4E20D487}" dt="2026-07-28T17:18:15.705" v="3" actId="20577"/>
-          <ac:spMkLst>
-            <pc:docMk/>
-            <pc:sldMk cId="0" sldId="256"/>
-            <ac:spMk id="2" creationId="{00000000-0000-0000-0000-000000000000}"/>
-          </ac:spMkLst>
-        </pc:spChg>
-        <pc:spChg chg="mod">
-          <ac:chgData name="Dmitriy Ratushny" userId="08050032e8047aee" providerId="LiveId" clId="{78EB1A6D-D3A9-4525-A4D5-A50D4E20D487}" dt="2026-07-28T17:18:55.324" v="31" actId="20577"/>
-          <ac:spMkLst>
-            <pc:docMk/>
-            <pc:sldMk cId="0" sldId="256"/>
-            <ac:spMk id="3" creationId="{00000000-0000-0000-0000-000000000000}"/>
-          </ac:spMkLst>
-        </pc:spChg>
-      </pc:sldChg>
-    </pc:docChg>
-  </pc:docChgLst>
-</pc:chgInfo>
-</file>
-
 <file path=ppt/notesMasters/notesMaster1.xml><?xml version="1.0" encoding="utf-8"?>
-<p:notesMaster xmlns:a="http://schemas.openxmlformats.org/drawingml/2006/main" xmlns:r="http://schemas.openxmlformats.org/officeDocument/2006/relationships" xmlns:p="http://schemas.openxmlformats.org/presentationml/2006/main">
+<p:notesMaster xmlns:a="http://schemas.openxmlformats.org/drawingml/2006/main" xmlns:p="http://schemas.openxmlformats.org/presentationml/2006/main" xmlns:r="http://schemas.openxmlformats.org/officeDocument/2006/relationships">
   <p:cSld>
     <p:bg>
       <p:bgRef idx="1001">
@@ -190,16 +134,241 @@
           <a:chExt cx="0" cy="0"/>
         </a:xfrm>
       </p:grpSpPr>
+      <p:sp>
+        <p:nvSpPr>
+          <p:cNvPr id="2" name="Header Placeholder 1"/>
+          <p:cNvSpPr>
+            <a:spLocks noGrp="1"/>
+          </p:cNvSpPr>
+          <p:nvPr>
+            <p:ph type="hdr" sz="quarter"/>
+          </p:nvPr>
+        </p:nvSpPr>
+        <p:spPr>
+          <a:xfrm>
+            <a:off x="0" y="0"/>
+            <a:ext cx="2971800" cy="457200"/>
+          </a:xfrm>
+          <a:prstGeom prst="rect">
+            <a:avLst/>
+          </a:prstGeom>
+        </p:spPr>
+        <p:txBody>
+          <a:bodyPr vert="horz" lIns="91440" tIns="45720" rIns="91440" bIns="45720" rtlCol="0"/>
+          <a:lstStyle>
+            <a:lvl1pPr algn="l">
+              <a:defRPr sz="1200"/>
+            </a:lvl1pPr>
+          </a:lstStyle>
+          <a:p>
+            <a:endParaRPr lang="en-US"/>
+          </a:p>
+        </p:txBody>
+      </p:sp>
+      <p:sp>
+        <p:nvSpPr>
+          <p:cNvPr id="3" name="Date Placeholder 2"/>
+          <p:cNvSpPr>
+            <a:spLocks noGrp="1"/>
+          </p:cNvSpPr>
+          <p:nvPr>
+            <p:ph type="dt" idx="1"/>
+          </p:nvPr>
+        </p:nvSpPr>
+        <p:spPr>
+          <a:xfrm>
+            <a:off x="3884613" y="0"/>
+            <a:ext cx="2971800" cy="457200"/>
+          </a:xfrm>
+          <a:prstGeom prst="rect">
+            <a:avLst/>
+          </a:prstGeom>
+        </p:spPr>
+        <p:txBody>
+          <a:bodyPr vert="horz" lIns="91440" tIns="45720" rIns="91440" bIns="45720" rtlCol="0"/>
+          <a:lstStyle>
+            <a:lvl1pPr algn="r">
+              <a:defRPr sz="1200"/>
+            </a:lvl1pPr>
+          </a:lstStyle>
+          <a:p>
+            <a:fld id="{0F89C1C7-3DCD-1040-A9CF-14679D8B5DDD}" type="datetimeFigureOut">
+              <a:rPr lang="en-US" smtClean="0"/>
+              <a:t>10/17/16</a:t>
+            </a:fld>
+            <a:endParaRPr lang="en-US"/>
+          </a:p>
+        </p:txBody>
+      </p:sp>
+      <p:sp>
+        <p:nvSpPr>
+          <p:cNvPr id="4" name="Slide Image Placeholder 3"/>
+          <p:cNvSpPr>
+            <a:spLocks noGrp="1" noRot="1" noChangeAspect="1"/>
+          </p:cNvSpPr>
+          <p:nvPr>
+            <p:ph type="sldImg" idx="2"/>
+          </p:nvPr>
+        </p:nvSpPr>
+        <p:spPr>
+          <a:xfrm>
+            <a:off x="1143000" y="685800"/>
+            <a:ext cx="4572000" cy="3429000"/>
+          </a:xfrm>
+          <a:prstGeom prst="rect">
+            <a:avLst/>
+          </a:prstGeom>
+          <a:noFill/>
+          <a:ln w="12700">
+            <a:solidFill>
+              <a:prstClr val="black"/>
+            </a:solidFill>
+          </a:ln>
+        </p:spPr>
+        <p:txBody>
+          <a:bodyPr vert="horz" lIns="91440" tIns="45720" rIns="91440" bIns="45720" rtlCol="0" anchor="ctr"/>
+          <a:lstStyle/>
+          <a:p>
+            <a:endParaRPr lang="en-US"/>
+          </a:p>
+        </p:txBody>
+      </p:sp>
+      <p:sp>
+        <p:nvSpPr>
+          <p:cNvPr id="5" name="Notes Placeholder 4"/>
+          <p:cNvSpPr>
+            <a:spLocks noGrp="1"/>
+          </p:cNvSpPr>
+          <p:nvPr>
+            <p:ph type="body" sz="quarter" idx="3"/>
+          </p:nvPr>
+        </p:nvSpPr>
+        <p:spPr>
+          <a:xfrm>
+            <a:off x="685800" y="4343400"/>
+            <a:ext cx="5486400" cy="4114800"/>
+          </a:xfrm>
+          <a:prstGeom prst="rect">
+            <a:avLst/>
+          </a:prstGeom>
+        </p:spPr>
+        <p:txBody>
+          <a:bodyPr vert="horz" lIns="91440" tIns="45720" rIns="91440" bIns="45720" rtlCol="0"/>
+          <a:lstStyle/>
+          <a:p>
+            <a:pPr lvl="0"/>
+            <a:r>
+              <a:rPr lang="en-US" smtClean="0"/>
+              <a:t>Click to edit Master text styles</a:t>
+            </a:r>
+          </a:p>
+          <a:p>
+            <a:pPr lvl="1"/>
+            <a:r>
+              <a:rPr lang="en-US" smtClean="0"/>
+              <a:t>Second level</a:t>
+            </a:r>
+          </a:p>
+          <a:p>
+            <a:pPr lvl="2"/>
+            <a:r>
+              <a:rPr lang="en-US" smtClean="0"/>
+              <a:t>Third level</a:t>
+            </a:r>
+          </a:p>
+          <a:p>
+            <a:pPr lvl="3"/>
+            <a:r>
+              <a:rPr lang="en-US" smtClean="0"/>
+              <a:t>Fourth level</a:t>
+            </a:r>
+          </a:p>
+          <a:p>
+            <a:pPr lvl="4"/>
+            <a:r>
+              <a:rPr lang="en-US" smtClean="0"/>
+              <a:t>Fifth level</a:t>
+            </a:r>
+            <a:endParaRPr lang="en-US"/>
+          </a:p>
+        </p:txBody>
+      </p:sp>
+      <p:sp>
+        <p:nvSpPr>
+          <p:cNvPr id="6" name="Footer Placeholder 5"/>
+          <p:cNvSpPr>
+            <a:spLocks noGrp="1"/>
+          </p:cNvSpPr>
+          <p:nvPr>
+            <p:ph type="ftr" sz="quarter" idx="4"/>
+          </p:nvPr>
+        </p:nvSpPr>
+        <p:spPr>
+          <a:xfrm>
+            <a:off x="0" y="8685213"/>
+            <a:ext cx="2971800" cy="457200"/>
+          </a:xfrm>
+          <a:prstGeom prst="rect">
+            <a:avLst/>
+          </a:prstGeom>
+        </p:spPr>
+        <p:txBody>
+          <a:bodyPr vert="horz" lIns="91440" tIns="45720" rIns="91440" bIns="45720" rtlCol="0" anchor="b"/>
+          <a:lstStyle>
+            <a:lvl1pPr algn="l">
+              <a:defRPr sz="1200"/>
+            </a:lvl1pPr>
+          </a:lstStyle>
+          <a:p>
+            <a:endParaRPr lang="en-US"/>
+          </a:p>
+        </p:txBody>
+      </p:sp>
+      <p:sp>
+        <p:nvSpPr>
+          <p:cNvPr id="7" name="Slide Number Placeholder 6"/>
+          <p:cNvSpPr>
+            <a:spLocks noGrp="1"/>
+          </p:cNvSpPr>
+          <p:nvPr>
+            <p:ph type="sldNum" sz="quarter" idx="5"/>
+          </p:nvPr>
+        </p:nvSpPr>
+        <p:spPr>
+          <a:xfrm>
+            <a:off x="3884613" y="8685213"/>
+            <a:ext cx="2971800" cy="457200"/>
+          </a:xfrm>
+          <a:prstGeom prst="rect">
+            <a:avLst/>
+          </a:prstGeom>
+        </p:spPr>
+        <p:txBody>
+          <a:bodyPr vert="horz" lIns="91440" tIns="45720" rIns="91440" bIns="45720" rtlCol="0" anchor="b"/>
+          <a:lstStyle>
+            <a:lvl1pPr algn="r">
+              <a:defRPr sz="1200"/>
+            </a:lvl1pPr>
+          </a:lstStyle>
+          <a:p>
+            <a:fld id="{BB5E49A5-4136-284D-997B-48E1D791AD67}" type="slidenum">
+              <a:rPr lang="en-US" smtClean="0"/>
+              <a:t>‹#›</a:t>
+            </a:fld>
+            <a:endParaRPr lang="en-US"/>
+          </a:p>
+        </p:txBody>
+      </p:sp>
     </p:spTree>
     <p:extLst>
       <p:ext uri="{BB962C8B-B14F-4D97-AF65-F5344CB8AC3E}">
-        <p14:creationId xmlns:p14="http://schemas.microsoft.com/office/powerpoint/2010/main" val="1303840188"/>
+        <p14:creationId xmlns:p14="http://schemas.microsoft.com/office/powerpoint/2010/main" val="2623252185"/>
       </p:ext>
     </p:extLst>
   </p:cSld>
   <p:clrMap bg1="lt1" tx1="dk1" bg2="lt2" tx2="dk2" accent1="accent1" accent2="accent2" accent3="accent3" accent4="accent4" accent5="accent5" accent6="accent6" hlink="hlink" folHlink="folHlink"/>
   <p:notesStyle>
-    <a:lvl1pPr marL="0" algn="l" defTabSz="914400" rtl="0" eaLnBrk="1" latinLnBrk="0" hangingPunct="1">
+    <a:lvl1pPr marL="0" algn="l" defTabSz="457200" rtl="0" eaLnBrk="1" latinLnBrk="0" hangingPunct="1">
       <a:defRPr sz="1200" kern="1200">
         <a:solidFill>
           <a:schemeClr val="tx1"/>
@@ -209,7 +378,7 @@
         <a:cs typeface="+mn-cs"/>
       </a:defRPr>
     </a:lvl1pPr>
-    <a:lvl2pPr marL="457200" algn="l" defTabSz="914400" rtl="0" eaLnBrk="1" latinLnBrk="0" hangingPunct="1">
+    <a:lvl2pPr marL="457200" algn="l" defTabSz="457200" rtl="0" eaLnBrk="1" latinLnBrk="0" hangingPunct="1">
       <a:defRPr sz="1200" kern="1200">
         <a:solidFill>
           <a:schemeClr val="tx1"/>
@@ -219,7 +388,7 @@
         <a:cs typeface="+mn-cs"/>
       </a:defRPr>
     </a:lvl2pPr>
-    <a:lvl3pPr marL="914400" algn="l" defTabSz="914400" rtl="0" eaLnBrk="1" latinLnBrk="0" hangingPunct="1">
+    <a:lvl3pPr marL="914400" algn="l" defTabSz="457200" rtl="0" eaLnBrk="1" latinLnBrk="0" hangingPunct="1">
       <a:defRPr sz="1200" kern="1200">
         <a:solidFill>
           <a:schemeClr val="tx1"/>
@@ -229,7 +398,7 @@
         <a:cs typeface="+mn-cs"/>
       </a:defRPr>
     </a:lvl3pPr>
-    <a:lvl4pPr marL="1371600" algn="l" defTabSz="914400" rtl="0" eaLnBrk="1" latinLnBrk="0" hangingPunct="1">
+    <a:lvl4pPr marL="1371600" algn="l" defTabSz="457200" rtl="0" eaLnBrk="1" latinLnBrk="0" hangingPunct="1">
       <a:defRPr sz="1200" kern="1200">
         <a:solidFill>
           <a:schemeClr val="tx1"/>
@@ -239,7 +408,7 @@
         <a:cs typeface="+mn-cs"/>
       </a:defRPr>
     </a:lvl4pPr>
-    <a:lvl5pPr marL="1828800" algn="l" defTabSz="914400" rtl="0" eaLnBrk="1" latinLnBrk="0" hangingPunct="1">
+    <a:lvl5pPr marL="1828800" algn="l" defTabSz="457200" rtl="0" eaLnBrk="1" latinLnBrk="0" hangingPunct="1">
       <a:defRPr sz="1200" kern="1200">
         <a:solidFill>
           <a:schemeClr val="tx1"/>
@@ -249,7 +418,7 @@
         <a:cs typeface="+mn-cs"/>
       </a:defRPr>
     </a:lvl5pPr>
-    <a:lvl6pPr marL="2286000" algn="l" defTabSz="914400" rtl="0" eaLnBrk="1" latinLnBrk="0" hangingPunct="1">
+    <a:lvl6pPr marL="2286000" algn="l" defTabSz="457200" rtl="0" eaLnBrk="1" latinLnBrk="0" hangingPunct="1">
       <a:defRPr sz="1200" kern="1200">
         <a:solidFill>
           <a:schemeClr val="tx1"/>
@@ -259,7 +428,7 @@
         <a:cs typeface="+mn-cs"/>
       </a:defRPr>
     </a:lvl6pPr>
-    <a:lvl7pPr marL="2743200" algn="l" defTabSz="914400" rtl="0" eaLnBrk="1" latinLnBrk="0" hangingPunct="1">
+    <a:lvl7pPr marL="2743200" algn="l" defTabSz="457200" rtl="0" eaLnBrk="1" latinLnBrk="0" hangingPunct="1">
       <a:defRPr sz="1200" kern="1200">
         <a:solidFill>
           <a:schemeClr val="tx1"/>
@@ -269,7 +438,7 @@
         <a:cs typeface="+mn-cs"/>
       </a:defRPr>
     </a:lvl7pPr>
-    <a:lvl8pPr marL="3200400" algn="l" defTabSz="914400" rtl="0" eaLnBrk="1" latinLnBrk="0" hangingPunct="1">
+    <a:lvl8pPr marL="3200400" algn="l" defTabSz="457200" rtl="0" eaLnBrk="1" latinLnBrk="0" hangingPunct="1">
       <a:defRPr sz="1200" kern="1200">
         <a:solidFill>
           <a:schemeClr val="tx1"/>
@@ -279,7 +448,7 @@
         <a:cs typeface="+mn-cs"/>
       </a:defRPr>
     </a:lvl8pPr>
-    <a:lvl9pPr marL="3657600" algn="l" defTabSz="914400" rtl="0" eaLnBrk="1" latinLnBrk="0" hangingPunct="1">
+    <a:lvl9pPr marL="3657600" algn="l" defTabSz="457200" rtl="0" eaLnBrk="1" latinLnBrk="0" hangingPunct="1">
       <a:defRPr sz="1200" kern="1200">
         <a:solidFill>
           <a:schemeClr val="tx1"/>
@@ -294,7 +463,7 @@
 </file>
 
 <file path=ppt/notesSlides/notesSlide1.xml><?xml version="1.0" encoding="utf-8"?>
-<p:notes xmlns:a="http://schemas.openxmlformats.org/drawingml/2006/main" xmlns:r="http://schemas.openxmlformats.org/officeDocument/2006/relationships" xmlns:p="http://schemas.openxmlformats.org/presentationml/2006/main">
+<p:notes xmlns:a="http://schemas.openxmlformats.org/drawingml/2006/main" xmlns:p="http://schemas.openxmlformats.org/presentationml/2006/main" xmlns:r="http://schemas.openxmlformats.org/officeDocument/2006/relationships">
   <p:cSld>
     <p:spTree>
       <p:nvGrpSpPr>
@@ -314,7 +483,7 @@
         <p:nvSpPr>
           <p:cNvPr id="2" name="Slide Image Placeholder 1"/>
           <p:cNvSpPr>
-            <a:spLocks noGrp="1" noRot="1" noChangeAspect="1"/>
+            <a:spLocks noGrp="1"/>
           </p:cNvSpPr>
           <p:nvPr>
             <p:ph type="sldImg" idx="2"/>
@@ -329,7 +498,7 @@
             <a:spLocks noGrp="1"/>
           </p:cNvSpPr>
           <p:nvPr>
-            <p:ph type="body" sz="quarter" idx="3"/>
+            <p:ph type="body" idx="3" sz="quarter"/>
           </p:nvPr>
         </p:nvSpPr>
         <p:spPr/>
@@ -350,7 +519,7 @@
             <a:spLocks noGrp="1"/>
           </p:cNvSpPr>
           <p:nvPr>
-            <p:ph type="sldNum" sz="quarter" idx="5"/>
+            <p:ph type="sldNum" idx="5" sz="quarter"/>
           </p:nvPr>
         </p:nvSpPr>
         <p:spPr/>
@@ -401,9 +570,10 @@
           <a:lstStyle/>
           <a:p>
             <a:r>
-              <a:rPr lang="en-US"/>
+              <a:rPr lang="en-US" smtClean="0"/>
               <a:t>Click to edit Master title style</a:t>
             </a:r>
+            <a:endParaRPr lang="en-US"/>
           </a:p>
         </p:txBody>
       </p:sp>
@@ -519,9 +689,10 @@
           </a:lstStyle>
           <a:p>
             <a:r>
-              <a:rPr lang="en-US"/>
+              <a:rPr lang="en-US" smtClean="0"/>
               <a:t>Click to edit Master subtitle style</a:t>
             </a:r>
+            <a:endParaRPr lang="en-US"/>
           </a:p>
         </p:txBody>
       </p:sp>
@@ -542,7 +713,7 @@
           <a:p>
             <a:fld id="{5BCAD085-E8A6-8845-BD4E-CB4CCA059FC4}" type="datetimeFigureOut">
               <a:rPr lang="en-US" smtClean="0"/>
-              <a:t>7/28/2026</a:t>
+              <a:t>1/27/13</a:t>
             </a:fld>
             <a:endParaRPr lang="en-US"/>
           </a:p>
@@ -636,9 +807,10 @@
           <a:lstStyle/>
           <a:p>
             <a:r>
-              <a:rPr lang="en-US"/>
+              <a:rPr lang="en-US" smtClean="0"/>
               <a:t>Click to edit Master title style</a:t>
             </a:r>
+            <a:endParaRPr lang="en-US"/>
           </a:p>
         </p:txBody>
       </p:sp>
@@ -659,37 +831,38 @@
           <a:p>
             <a:pPr lvl="0"/>
             <a:r>
-              <a:rPr lang="en-US"/>
+              <a:rPr lang="en-US" smtClean="0"/>
               <a:t>Click to edit Master text styles</a:t>
             </a:r>
           </a:p>
           <a:p>
             <a:pPr lvl="1"/>
             <a:r>
-              <a:rPr lang="en-US"/>
+              <a:rPr lang="en-US" smtClean="0"/>
               <a:t>Second level</a:t>
             </a:r>
           </a:p>
           <a:p>
             <a:pPr lvl="2"/>
             <a:r>
-              <a:rPr lang="en-US"/>
+              <a:rPr lang="en-US" smtClean="0"/>
               <a:t>Third level</a:t>
             </a:r>
           </a:p>
           <a:p>
             <a:pPr lvl="3"/>
             <a:r>
-              <a:rPr lang="en-US"/>
+              <a:rPr lang="en-US" smtClean="0"/>
               <a:t>Fourth level</a:t>
             </a:r>
           </a:p>
           <a:p>
             <a:pPr lvl="4"/>
             <a:r>
-              <a:rPr lang="en-US"/>
+              <a:rPr lang="en-US" smtClean="0"/>
               <a:t>Fifth level</a:t>
             </a:r>
+            <a:endParaRPr lang="en-US"/>
           </a:p>
         </p:txBody>
       </p:sp>
@@ -710,7 +883,7 @@
           <a:p>
             <a:fld id="{5BCAD085-E8A6-8845-BD4E-CB4CCA059FC4}" type="datetimeFigureOut">
               <a:rPr lang="en-US" smtClean="0"/>
-              <a:t>7/28/2026</a:t>
+              <a:t>1/27/13</a:t>
             </a:fld>
             <a:endParaRPr lang="en-US"/>
           </a:p>
@@ -809,9 +982,10 @@
           <a:lstStyle/>
           <a:p>
             <a:r>
-              <a:rPr lang="en-US"/>
+              <a:rPr lang="en-US" smtClean="0"/>
               <a:t>Click to edit Master title style</a:t>
             </a:r>
+            <a:endParaRPr lang="en-US"/>
           </a:p>
         </p:txBody>
       </p:sp>
@@ -837,37 +1011,38 @@
           <a:p>
             <a:pPr lvl="0"/>
             <a:r>
-              <a:rPr lang="en-US"/>
+              <a:rPr lang="en-US" smtClean="0"/>
               <a:t>Click to edit Master text styles</a:t>
             </a:r>
           </a:p>
           <a:p>
             <a:pPr lvl="1"/>
             <a:r>
-              <a:rPr lang="en-US"/>
+              <a:rPr lang="en-US" smtClean="0"/>
               <a:t>Second level</a:t>
             </a:r>
           </a:p>
           <a:p>
             <a:pPr lvl="2"/>
             <a:r>
-              <a:rPr lang="en-US"/>
+              <a:rPr lang="en-US" smtClean="0"/>
               <a:t>Third level</a:t>
             </a:r>
           </a:p>
           <a:p>
             <a:pPr lvl="3"/>
             <a:r>
-              <a:rPr lang="en-US"/>
+              <a:rPr lang="en-US" smtClean="0"/>
               <a:t>Fourth level</a:t>
             </a:r>
           </a:p>
           <a:p>
             <a:pPr lvl="4"/>
             <a:r>
-              <a:rPr lang="en-US"/>
+              <a:rPr lang="en-US" smtClean="0"/>
               <a:t>Fifth level</a:t>
             </a:r>
+            <a:endParaRPr lang="en-US"/>
           </a:p>
         </p:txBody>
       </p:sp>
@@ -888,7 +1063,7 @@
           <a:p>
             <a:fld id="{5BCAD085-E8A6-8845-BD4E-CB4CCA059FC4}" type="datetimeFigureOut">
               <a:rPr lang="en-US" smtClean="0"/>
-              <a:t>7/28/2026</a:t>
+              <a:t>1/27/13</a:t>
             </a:fld>
             <a:endParaRPr lang="en-US"/>
           </a:p>
@@ -982,9 +1157,10 @@
           <a:lstStyle/>
           <a:p>
             <a:r>
-              <a:rPr lang="en-US"/>
+              <a:rPr lang="en-US" smtClean="0"/>
               <a:t>Click to edit Master title style</a:t>
             </a:r>
+            <a:endParaRPr lang="en-US"/>
           </a:p>
         </p:txBody>
       </p:sp>
@@ -1005,37 +1181,38 @@
           <a:p>
             <a:pPr lvl="0"/>
             <a:r>
-              <a:rPr lang="en-US"/>
+              <a:rPr lang="en-US" smtClean="0"/>
               <a:t>Click to edit Master text styles</a:t>
             </a:r>
           </a:p>
           <a:p>
             <a:pPr lvl="1"/>
             <a:r>
-              <a:rPr lang="en-US"/>
+              <a:rPr lang="en-US" smtClean="0"/>
               <a:t>Second level</a:t>
             </a:r>
           </a:p>
           <a:p>
             <a:pPr lvl="2"/>
             <a:r>
-              <a:rPr lang="en-US"/>
+              <a:rPr lang="en-US" smtClean="0"/>
               <a:t>Third level</a:t>
             </a:r>
           </a:p>
           <a:p>
             <a:pPr lvl="3"/>
             <a:r>
-              <a:rPr lang="en-US"/>
+              <a:rPr lang="en-US" smtClean="0"/>
               <a:t>Fourth level</a:t>
             </a:r>
           </a:p>
           <a:p>
             <a:pPr lvl="4"/>
             <a:r>
-              <a:rPr lang="en-US"/>
+              <a:rPr lang="en-US" smtClean="0"/>
               <a:t>Fifth level</a:t>
             </a:r>
+            <a:endParaRPr lang="en-US"/>
           </a:p>
         </p:txBody>
       </p:sp>
@@ -1056,7 +1233,7 @@
           <a:p>
             <a:fld id="{5BCAD085-E8A6-8845-BD4E-CB4CCA059FC4}" type="datetimeFigureOut">
               <a:rPr lang="en-US" smtClean="0"/>
-              <a:t>7/28/2026</a:t>
+              <a:t>1/27/13</a:t>
             </a:fld>
             <a:endParaRPr lang="en-US"/>
           </a:p>
@@ -1159,9 +1336,10 @@
           </a:lstStyle>
           <a:p>
             <a:r>
-              <a:rPr lang="en-US"/>
+              <a:rPr lang="en-US" smtClean="0"/>
               <a:t>Click to edit Master title style</a:t>
             </a:r>
+            <a:endParaRPr lang="en-US"/>
           </a:p>
         </p:txBody>
       </p:sp>
@@ -1278,7 +1456,7 @@
           <a:p>
             <a:pPr lvl="0"/>
             <a:r>
-              <a:rPr lang="en-US"/>
+              <a:rPr lang="en-US" smtClean="0"/>
               <a:t>Click to edit Master text styles</a:t>
             </a:r>
           </a:p>
@@ -1301,7 +1479,7 @@
           <a:p>
             <a:fld id="{5BCAD085-E8A6-8845-BD4E-CB4CCA059FC4}" type="datetimeFigureOut">
               <a:rPr lang="en-US" smtClean="0"/>
-              <a:t>7/28/2026</a:t>
+              <a:t>1/27/13</a:t>
             </a:fld>
             <a:endParaRPr lang="en-US"/>
           </a:p>
@@ -1395,9 +1573,10 @@
           <a:lstStyle/>
           <a:p>
             <a:r>
-              <a:rPr lang="en-US"/>
+              <a:rPr lang="en-US" smtClean="0"/>
               <a:t>Click to edit Master title style</a:t>
             </a:r>
+            <a:endParaRPr lang="en-US"/>
           </a:p>
         </p:txBody>
       </p:sp>
@@ -1451,37 +1630,38 @@
           <a:p>
             <a:pPr lvl="0"/>
             <a:r>
-              <a:rPr lang="en-US"/>
+              <a:rPr lang="en-US" smtClean="0"/>
               <a:t>Click to edit Master text styles</a:t>
             </a:r>
           </a:p>
           <a:p>
             <a:pPr lvl="1"/>
             <a:r>
-              <a:rPr lang="en-US"/>
+              <a:rPr lang="en-US" smtClean="0"/>
               <a:t>Second level</a:t>
             </a:r>
           </a:p>
           <a:p>
             <a:pPr lvl="2"/>
             <a:r>
-              <a:rPr lang="en-US"/>
+              <a:rPr lang="en-US" smtClean="0"/>
               <a:t>Third level</a:t>
             </a:r>
           </a:p>
           <a:p>
             <a:pPr lvl="3"/>
             <a:r>
-              <a:rPr lang="en-US"/>
+              <a:rPr lang="en-US" smtClean="0"/>
               <a:t>Fourth level</a:t>
             </a:r>
           </a:p>
           <a:p>
             <a:pPr lvl="4"/>
             <a:r>
-              <a:rPr lang="en-US"/>
+              <a:rPr lang="en-US" smtClean="0"/>
               <a:t>Fifth level</a:t>
             </a:r>
+            <a:endParaRPr lang="en-US"/>
           </a:p>
         </p:txBody>
       </p:sp>
@@ -1535,37 +1715,38 @@
           <a:p>
             <a:pPr lvl="0"/>
             <a:r>
-              <a:rPr lang="en-US"/>
+              <a:rPr lang="en-US" smtClean="0"/>
               <a:t>Click to edit Master text styles</a:t>
             </a:r>
           </a:p>
           <a:p>
             <a:pPr lvl="1"/>
             <a:r>
-              <a:rPr lang="en-US"/>
+              <a:rPr lang="en-US" smtClean="0"/>
               <a:t>Second level</a:t>
             </a:r>
           </a:p>
           <a:p>
             <a:pPr lvl="2"/>
             <a:r>
-              <a:rPr lang="en-US"/>
+              <a:rPr lang="en-US" smtClean="0"/>
               <a:t>Third level</a:t>
             </a:r>
           </a:p>
           <a:p>
             <a:pPr lvl="3"/>
             <a:r>
-              <a:rPr lang="en-US"/>
+              <a:rPr lang="en-US" smtClean="0"/>
               <a:t>Fourth level</a:t>
             </a:r>
           </a:p>
           <a:p>
             <a:pPr lvl="4"/>
             <a:r>
-              <a:rPr lang="en-US"/>
+              <a:rPr lang="en-US" smtClean="0"/>
               <a:t>Fifth level</a:t>
             </a:r>
+            <a:endParaRPr lang="en-US"/>
           </a:p>
         </p:txBody>
       </p:sp>
@@ -1586,7 +1767,7 @@
           <a:p>
             <a:fld id="{5BCAD085-E8A6-8845-BD4E-CB4CCA059FC4}" type="datetimeFigureOut">
               <a:rPr lang="en-US" smtClean="0"/>
-              <a:t>7/28/2026</a:t>
+              <a:t>1/27/13</a:t>
             </a:fld>
             <a:endParaRPr lang="en-US"/>
           </a:p>
@@ -1684,9 +1865,10 @@
           </a:lstStyle>
           <a:p>
             <a:r>
-              <a:rPr lang="en-US"/>
+              <a:rPr lang="en-US" smtClean="0"/>
               <a:t>Click to edit Master title style</a:t>
             </a:r>
+            <a:endParaRPr lang="en-US"/>
           </a:p>
         </p:txBody>
       </p:sp>
@@ -1749,7 +1931,7 @@
           <a:p>
             <a:pPr lvl="0"/>
             <a:r>
-              <a:rPr lang="en-US"/>
+              <a:rPr lang="en-US" smtClean="0"/>
               <a:t>Click to edit Master text styles</a:t>
             </a:r>
           </a:p>
@@ -1805,37 +1987,38 @@
           <a:p>
             <a:pPr lvl="0"/>
             <a:r>
-              <a:rPr lang="en-US"/>
+              <a:rPr lang="en-US" smtClean="0"/>
               <a:t>Click to edit Master text styles</a:t>
             </a:r>
           </a:p>
           <a:p>
             <a:pPr lvl="1"/>
             <a:r>
-              <a:rPr lang="en-US"/>
+              <a:rPr lang="en-US" smtClean="0"/>
               <a:t>Second level</a:t>
             </a:r>
           </a:p>
           <a:p>
             <a:pPr lvl="2"/>
             <a:r>
-              <a:rPr lang="en-US"/>
+              <a:rPr lang="en-US" smtClean="0"/>
               <a:t>Third level</a:t>
             </a:r>
           </a:p>
           <a:p>
             <a:pPr lvl="3"/>
             <a:r>
-              <a:rPr lang="en-US"/>
+              <a:rPr lang="en-US" smtClean="0"/>
               <a:t>Fourth level</a:t>
             </a:r>
           </a:p>
           <a:p>
             <a:pPr lvl="4"/>
             <a:r>
-              <a:rPr lang="en-US"/>
+              <a:rPr lang="en-US" smtClean="0"/>
               <a:t>Fifth level</a:t>
             </a:r>
+            <a:endParaRPr lang="en-US"/>
           </a:p>
         </p:txBody>
       </p:sp>
@@ -1898,7 +2081,7 @@
           <a:p>
             <a:pPr lvl="0"/>
             <a:r>
-              <a:rPr lang="en-US"/>
+              <a:rPr lang="en-US" smtClean="0"/>
               <a:t>Click to edit Master text styles</a:t>
             </a:r>
           </a:p>
@@ -1954,37 +2137,38 @@
           <a:p>
             <a:pPr lvl="0"/>
             <a:r>
-              <a:rPr lang="en-US"/>
+              <a:rPr lang="en-US" smtClean="0"/>
               <a:t>Click to edit Master text styles</a:t>
             </a:r>
           </a:p>
           <a:p>
             <a:pPr lvl="1"/>
             <a:r>
-              <a:rPr lang="en-US"/>
+              <a:rPr lang="en-US" smtClean="0"/>
               <a:t>Second level</a:t>
             </a:r>
           </a:p>
           <a:p>
             <a:pPr lvl="2"/>
             <a:r>
-              <a:rPr lang="en-US"/>
+              <a:rPr lang="en-US" smtClean="0"/>
               <a:t>Third level</a:t>
             </a:r>
           </a:p>
           <a:p>
             <a:pPr lvl="3"/>
             <a:r>
-              <a:rPr lang="en-US"/>
+              <a:rPr lang="en-US" smtClean="0"/>
               <a:t>Fourth level</a:t>
             </a:r>
           </a:p>
           <a:p>
             <a:pPr lvl="4"/>
             <a:r>
-              <a:rPr lang="en-US"/>
+              <a:rPr lang="en-US" smtClean="0"/>
               <a:t>Fifth level</a:t>
             </a:r>
+            <a:endParaRPr lang="en-US"/>
           </a:p>
         </p:txBody>
       </p:sp>
@@ -2005,7 +2189,7 @@
           <a:p>
             <a:fld id="{5BCAD085-E8A6-8845-BD4E-CB4CCA059FC4}" type="datetimeFigureOut">
               <a:rPr lang="en-US" smtClean="0"/>
-              <a:t>7/28/2026</a:t>
+              <a:t>1/27/13</a:t>
             </a:fld>
             <a:endParaRPr lang="en-US"/>
           </a:p>
@@ -2099,9 +2283,10 @@
           <a:lstStyle/>
           <a:p>
             <a:r>
-              <a:rPr lang="en-US"/>
+              <a:rPr lang="en-US" smtClean="0"/>
               <a:t>Click to edit Master title style</a:t>
             </a:r>
+            <a:endParaRPr lang="en-US"/>
           </a:p>
         </p:txBody>
       </p:sp>
@@ -2122,7 +2307,7 @@
           <a:p>
             <a:fld id="{5BCAD085-E8A6-8845-BD4E-CB4CCA059FC4}" type="datetimeFigureOut">
               <a:rPr lang="en-US" smtClean="0"/>
-              <a:t>7/28/2026</a:t>
+              <a:t>1/27/13</a:t>
             </a:fld>
             <a:endParaRPr lang="en-US"/>
           </a:p>
@@ -2217,7 +2402,7 @@
           <a:p>
             <a:fld id="{5BCAD085-E8A6-8845-BD4E-CB4CCA059FC4}" type="datetimeFigureOut">
               <a:rPr lang="en-US" smtClean="0"/>
-              <a:t>7/28/2026</a:t>
+              <a:t>1/27/13</a:t>
             </a:fld>
             <a:endParaRPr lang="en-US"/>
           </a:p>
@@ -2320,9 +2505,10 @@
           </a:lstStyle>
           <a:p>
             <a:r>
-              <a:rPr lang="en-US"/>
+              <a:rPr lang="en-US" smtClean="0"/>
               <a:t>Click to edit Master title style</a:t>
             </a:r>
+            <a:endParaRPr lang="en-US"/>
           </a:p>
         </p:txBody>
       </p:sp>
@@ -2376,37 +2562,38 @@
           <a:p>
             <a:pPr lvl="0"/>
             <a:r>
-              <a:rPr lang="en-US"/>
+              <a:rPr lang="en-US" smtClean="0"/>
               <a:t>Click to edit Master text styles</a:t>
             </a:r>
           </a:p>
           <a:p>
             <a:pPr lvl="1"/>
             <a:r>
-              <a:rPr lang="en-US"/>
+              <a:rPr lang="en-US" smtClean="0"/>
               <a:t>Second level</a:t>
             </a:r>
           </a:p>
           <a:p>
             <a:pPr lvl="2"/>
             <a:r>
-              <a:rPr lang="en-US"/>
+              <a:rPr lang="en-US" smtClean="0"/>
               <a:t>Third level</a:t>
             </a:r>
           </a:p>
           <a:p>
             <a:pPr lvl="3"/>
             <a:r>
-              <a:rPr lang="en-US"/>
+              <a:rPr lang="en-US" smtClean="0"/>
               <a:t>Fourth level</a:t>
             </a:r>
           </a:p>
           <a:p>
             <a:pPr lvl="4"/>
             <a:r>
-              <a:rPr lang="en-US"/>
+              <a:rPr lang="en-US" smtClean="0"/>
               <a:t>Fifth level</a:t>
             </a:r>
+            <a:endParaRPr lang="en-US"/>
           </a:p>
         </p:txBody>
       </p:sp>
@@ -2469,7 +2656,7 @@
           <a:p>
             <a:pPr lvl="0"/>
             <a:r>
-              <a:rPr lang="en-US"/>
+              <a:rPr lang="en-US" smtClean="0"/>
               <a:t>Click to edit Master text styles</a:t>
             </a:r>
           </a:p>
@@ -2492,7 +2679,7 @@
           <a:p>
             <a:fld id="{5BCAD085-E8A6-8845-BD4E-CB4CCA059FC4}" type="datetimeFigureOut">
               <a:rPr lang="en-US" smtClean="0"/>
-              <a:t>7/28/2026</a:t>
+              <a:t>1/27/13</a:t>
             </a:fld>
             <a:endParaRPr lang="en-US"/>
           </a:p>
@@ -2595,9 +2782,10 @@
           </a:lstStyle>
           <a:p>
             <a:r>
-              <a:rPr lang="en-US"/>
+              <a:rPr lang="en-US" smtClean="0"/>
               <a:t>Click to edit Master title style</a:t>
             </a:r>
+            <a:endParaRPr lang="en-US"/>
           </a:p>
         </p:txBody>
       </p:sp>
@@ -2721,7 +2909,7 @@
           <a:p>
             <a:pPr lvl="0"/>
             <a:r>
-              <a:rPr lang="en-US"/>
+              <a:rPr lang="en-US" smtClean="0"/>
               <a:t>Click to edit Master text styles</a:t>
             </a:r>
           </a:p>
@@ -2744,7 +2932,7 @@
           <a:p>
             <a:fld id="{5BCAD085-E8A6-8845-BD4E-CB4CCA059FC4}" type="datetimeFigureOut">
               <a:rPr lang="en-US" smtClean="0"/>
-              <a:t>7/28/2026</a:t>
+              <a:t>1/27/13</a:t>
             </a:fld>
             <a:endParaRPr lang="en-US"/>
           </a:p>
@@ -2853,9 +3041,10 @@
           <a:lstStyle/>
           <a:p>
             <a:r>
-              <a:rPr lang="en-US"/>
+              <a:rPr lang="en-US" smtClean="0"/>
               <a:t>Click to edit Master title style</a:t>
             </a:r>
+            <a:endParaRPr lang="en-US"/>
           </a:p>
         </p:txBody>
       </p:sp>
@@ -2886,37 +3075,38 @@
           <a:p>
             <a:pPr lvl="0"/>
             <a:r>
-              <a:rPr lang="en-US"/>
+              <a:rPr lang="en-US" smtClean="0"/>
               <a:t>Click to edit Master text styles</a:t>
             </a:r>
           </a:p>
           <a:p>
             <a:pPr lvl="1"/>
             <a:r>
-              <a:rPr lang="en-US"/>
+              <a:rPr lang="en-US" smtClean="0"/>
               <a:t>Second level</a:t>
             </a:r>
           </a:p>
           <a:p>
             <a:pPr lvl="2"/>
             <a:r>
-              <a:rPr lang="en-US"/>
+              <a:rPr lang="en-US" smtClean="0"/>
               <a:t>Third level</a:t>
             </a:r>
           </a:p>
           <a:p>
             <a:pPr lvl="3"/>
             <a:r>
-              <a:rPr lang="en-US"/>
+              <a:rPr lang="en-US" smtClean="0"/>
               <a:t>Fourth level</a:t>
             </a:r>
           </a:p>
           <a:p>
             <a:pPr lvl="4"/>
             <a:r>
-              <a:rPr lang="en-US"/>
+              <a:rPr lang="en-US" smtClean="0"/>
               <a:t>Fifth level</a:t>
             </a:r>
+            <a:endParaRPr lang="en-US"/>
           </a:p>
         </p:txBody>
       </p:sp>
@@ -2955,7 +3145,7 @@
           <a:p>
             <a:fld id="{5BCAD085-E8A6-8845-BD4E-CB4CCA059FC4}" type="datetimeFigureOut">
               <a:rPr lang="en-US" smtClean="0"/>
-              <a:t>7/28/2026</a:t>
+              <a:t>1/27/13</a:t>
             </a:fld>
             <a:endParaRPr lang="en-US"/>
           </a:p>
@@ -3314,7 +3504,7 @@
 </file>
 
 <file path=ppt/slides/slide1.xml><?xml version="1.0" encoding="utf-8"?>
-<p:sld xmlns:a="http://schemas.openxmlformats.org/drawingml/2006/main" xmlns:r="http://schemas.openxmlformats.org/officeDocument/2006/relationships" xmlns:p="http://schemas.openxmlformats.org/presentationml/2006/main">
+<p:sld xmlns:a="http://schemas.openxmlformats.org/drawingml/2006/main" xmlns:p="http://schemas.openxmlformats.org/presentationml/2006/main" xmlns:r="http://schemas.openxmlformats.org/officeDocument/2006/relationships">
   <p:cSld>
     <p:spTree>
       <p:nvGrpSpPr>
@@ -3322,14 +3512,7 @@
         <p:cNvGrpSpPr/>
         <p:nvPr/>
       </p:nvGrpSpPr>
-      <p:grpSpPr>
-        <a:xfrm>
-          <a:off x="0" y="0"/>
-          <a:ext cx="0" cy="0"/>
-          <a:chOff x="0" y="0"/>
-          <a:chExt cx="0" cy="0"/>
-        </a:xfrm>
-      </p:grpSpPr>
+      <p:grpSpPr/>
       <p:sp>
         <p:nvSpPr>
           <p:cNvPr id="2" name="TextBox 1"/>
@@ -3339,7 +3522,7 @@
         <p:spPr>
           <a:xfrm>
             <a:off x="685800" y="1371600"/>
-            <a:ext cx="10820095" cy="1123384"/>
+            <a:ext cx="10820095" cy="2011680"/>
           </a:xfrm>
           <a:prstGeom prst="rect">
             <a:avLst/>
@@ -3353,7 +3536,7 @@
           <a:lstStyle/>
           <a:p>
             <a:r>
-              <a:rPr sz="4000" b="1" i="0" dirty="0">
+              <a:rPr sz="4000" b="1" i="0">
                 <a:solidFill>
                   <a:srgbClr val="1A1A1A"/>
                 </a:solidFill>
@@ -3369,29 +3552,14 @@
               </a:spcBef>
             </a:pPr>
             <a:r>
-              <a:rPr sz="1700" b="0" i="0" dirty="0">
+              <a:rPr sz="1700" b="0" i="0">
                 <a:solidFill>
                   <a:srgbClr val="5A6270"/>
                 </a:solidFill>
                 <a:latin typeface="Calibri"/>
               </a:rPr>
-              <a:t>Executive summary</a:t>
-            </a:r>
-            <a:r>
-              <a:rPr lang="en-US" sz="1700" dirty="0">
-                <a:solidFill>
-                  <a:srgbClr val="5A6270"/>
-                </a:solidFill>
-                <a:latin typeface="Calibri"/>
-              </a:rPr>
-              <a:t>:</a:t>
-            </a:r>
-            <a:endParaRPr sz="1700" b="0" i="0" dirty="0">
-              <a:solidFill>
-                <a:srgbClr val="5A6270"/>
-              </a:solidFill>
-              <a:latin typeface="Calibri"/>
-            </a:endParaRPr>
+              <a:t>Executive summary. You asked three questions. Here are the three answers.</a:t>
+            </a:r>
           </a:p>
         </p:txBody>
       </p:sp>
@@ -3404,7 +3572,7 @@
         <p:spPr>
           <a:xfrm>
             <a:off x="685800" y="3200400"/>
-            <a:ext cx="10820095" cy="2141612"/>
+            <a:ext cx="10820095" cy="4572000"/>
           </a:xfrm>
           <a:prstGeom prst="rect">
             <a:avLst/>
@@ -3423,7 +3591,7 @@
               </a:spcAft>
             </a:pPr>
             <a:r>
-              <a:rPr sz="1600" b="1" i="0" dirty="0">
+              <a:rPr sz="1600" b="1" i="0">
                 <a:solidFill>
                   <a:srgbClr val="1A1A1A"/>
                 </a:solidFill>
@@ -3439,7 +3607,7 @@
               </a:spcAft>
             </a:pPr>
             <a:r>
-              <a:rPr sz="1400" b="0" i="0" dirty="0">
+              <a:rPr sz="1400" b="0" i="0">
                 <a:solidFill>
                   <a:srgbClr val="1A1A1A"/>
                 </a:solidFill>
@@ -3455,7 +3623,7 @@
               </a:spcAft>
             </a:pPr>
             <a:r>
-              <a:rPr sz="1600" b="1" i="0" dirty="0">
+              <a:rPr sz="1600" b="1" i="0">
                 <a:solidFill>
                   <a:srgbClr val="1A1A1A"/>
                 </a:solidFill>
@@ -3471,7 +3639,7 @@
               </a:spcAft>
             </a:pPr>
             <a:r>
-              <a:rPr sz="1400" b="0" i="0" dirty="0">
+              <a:rPr sz="1400" b="0" i="0">
                 <a:solidFill>
                   <a:srgbClr val="B02E2E"/>
                 </a:solidFill>
@@ -3487,7 +3655,7 @@
               </a:spcAft>
             </a:pPr>
             <a:r>
-              <a:rPr sz="1600" b="1" i="0" dirty="0">
+              <a:rPr sz="1600" b="1" i="0">
                 <a:solidFill>
                   <a:srgbClr val="1A1A1A"/>
                 </a:solidFill>
@@ -3503,40 +3671,13 @@
               </a:spcAft>
             </a:pPr>
             <a:r>
-              <a:rPr lang="en-US" sz="1400" b="0" i="0" dirty="0">
+              <a:rPr sz="1400" b="0" i="0">
                 <a:solidFill>
                   <a:srgbClr val="1E7A4B"/>
                 </a:solidFill>
                 <a:latin typeface="Calibri"/>
               </a:rPr>
-              <a:t>Contacting</a:t>
-            </a:r>
-            <a:r>
-              <a:rPr sz="1400" b="0" i="0" dirty="0">
-                <a:solidFill>
-                  <a:srgbClr val="1E7A4B"/>
-                </a:solidFill>
-                <a:latin typeface="Calibri"/>
-              </a:rPr>
-              <a:t> every at-risk customer</a:t>
-            </a:r>
-            <a:r>
-              <a:rPr lang="en-US" sz="1400" b="0" i="0" dirty="0">
-                <a:solidFill>
-                  <a:srgbClr val="1E7A4B"/>
-                </a:solidFill>
-                <a:latin typeface="Calibri"/>
-              </a:rPr>
-              <a:t> as intervention</a:t>
-            </a:r>
-            <a:r>
-              <a:rPr sz="1400" b="0" i="0" dirty="0">
-                <a:solidFill>
-                  <a:srgbClr val="1E7A4B"/>
-                </a:solidFill>
-                <a:latin typeface="Calibri"/>
-              </a:rPr>
-              <a:t> already pays for itself today. Beyond that we cannot yet prove what works, because we have never recorded taking an action.</a:t>
+              <a:t>Calling every at-risk customer already pays for itself today. Beyond that we cannot yet prove what works, because we have never recorded taking an action.</a:t>
             </a:r>
           </a:p>
         </p:txBody>
@@ -3550,7 +3691,7 @@
 </file>
 
 <file path=ppt/slides/slide2.xml><?xml version="1.0" encoding="utf-8"?>
-<p:sld xmlns:a="http://schemas.openxmlformats.org/drawingml/2006/main" xmlns:r="http://schemas.openxmlformats.org/officeDocument/2006/relationships" xmlns:p="http://schemas.openxmlformats.org/presentationml/2006/main">
+<p:sld xmlns:a="http://schemas.openxmlformats.org/drawingml/2006/main" xmlns:p="http://schemas.openxmlformats.org/presentationml/2006/main" xmlns:r="http://schemas.openxmlformats.org/officeDocument/2006/relationships">
   <p:cSld>
     <p:spTree>
       <p:nvGrpSpPr>
@@ -3558,14 +3699,7 @@
         <p:cNvGrpSpPr/>
         <p:nvPr/>
       </p:nvGrpSpPr>
-      <p:grpSpPr>
-        <a:xfrm>
-          <a:off x="0" y="0"/>
-          <a:ext cx="0" cy="0"/>
-          <a:chOff x="0" y="0"/>
-          <a:chExt cx="0" cy="0"/>
-        </a:xfrm>
-      </p:grpSpPr>
+      <p:grpSpPr/>
       <p:sp>
         <p:nvSpPr>
           <p:cNvPr id="2" name="TextBox 1"/>
@@ -3657,7 +3791,6 @@
           <a:lstStyle/>
           <a:p>
             <a:pPr algn="ctr"/>
-            <a:endParaRPr/>
           </a:p>
         </p:txBody>
       </p:sp>
@@ -3799,7 +3932,7 @@
 </file>
 
 <file path=ppt/slides/slide3.xml><?xml version="1.0" encoding="utf-8"?>
-<p:sld xmlns:a="http://schemas.openxmlformats.org/drawingml/2006/main" xmlns:r="http://schemas.openxmlformats.org/officeDocument/2006/relationships" xmlns:p="http://schemas.openxmlformats.org/presentationml/2006/main">
+<p:sld xmlns:a="http://schemas.openxmlformats.org/drawingml/2006/main" xmlns:p="http://schemas.openxmlformats.org/presentationml/2006/main" xmlns:r="http://schemas.openxmlformats.org/officeDocument/2006/relationships">
   <p:cSld>
     <p:spTree>
       <p:nvGrpSpPr>
@@ -3807,14 +3940,7 @@
         <p:cNvGrpSpPr/>
         <p:nvPr/>
       </p:nvGrpSpPr>
-      <p:grpSpPr>
-        <a:xfrm>
-          <a:off x="0" y="0"/>
-          <a:ext cx="0" cy="0"/>
-          <a:chOff x="0" y="0"/>
-          <a:chExt cx="0" cy="0"/>
-        </a:xfrm>
-      </p:grpSpPr>
+      <p:grpSpPr/>
       <p:sp>
         <p:nvSpPr>
           <p:cNvPr id="2" name="TextBox 1"/>
@@ -3906,7 +4032,6 @@
           <a:lstStyle/>
           <a:p>
             <a:pPr algn="ctr"/>
-            <a:endParaRPr/>
           </a:p>
         </p:txBody>
       </p:sp>
@@ -4152,7 +4277,7 @@
 </file>
 
 <file path=ppt/slides/slide4.xml><?xml version="1.0" encoding="utf-8"?>
-<p:sld xmlns:a="http://schemas.openxmlformats.org/drawingml/2006/main" xmlns:r="http://schemas.openxmlformats.org/officeDocument/2006/relationships" xmlns:p="http://schemas.openxmlformats.org/presentationml/2006/main">
+<p:sld xmlns:a="http://schemas.openxmlformats.org/drawingml/2006/main" xmlns:p="http://schemas.openxmlformats.org/presentationml/2006/main" xmlns:r="http://schemas.openxmlformats.org/officeDocument/2006/relationships">
   <p:cSld>
     <p:spTree>
       <p:nvGrpSpPr>
@@ -4160,14 +4285,7 @@
         <p:cNvGrpSpPr/>
         <p:nvPr/>
       </p:nvGrpSpPr>
-      <p:grpSpPr>
-        <a:xfrm>
-          <a:off x="0" y="0"/>
-          <a:ext cx="0" cy="0"/>
-          <a:chOff x="0" y="0"/>
-          <a:chExt cx="0" cy="0"/>
-        </a:xfrm>
-      </p:grpSpPr>
+      <p:grpSpPr/>
       <p:sp>
         <p:nvSpPr>
           <p:cNvPr id="2" name="TextBox 1"/>
@@ -4259,7 +4377,6 @@
           <a:lstStyle/>
           <a:p>
             <a:pPr algn="ctr"/>
-            <a:endParaRPr/>
           </a:p>
         </p:txBody>
       </p:sp>
@@ -4507,7 +4624,7 @@
 </file>
 
 <file path=ppt/slides/slide5.xml><?xml version="1.0" encoding="utf-8"?>
-<p:sld xmlns:a="http://schemas.openxmlformats.org/drawingml/2006/main" xmlns:r="http://schemas.openxmlformats.org/officeDocument/2006/relationships" xmlns:p="http://schemas.openxmlformats.org/presentationml/2006/main">
+<p:sld xmlns:a="http://schemas.openxmlformats.org/drawingml/2006/main" xmlns:p="http://schemas.openxmlformats.org/presentationml/2006/main" xmlns:r="http://schemas.openxmlformats.org/officeDocument/2006/relationships">
   <p:cSld>
     <p:spTree>
       <p:nvGrpSpPr>
@@ -4515,14 +4632,7 @@
         <p:cNvGrpSpPr/>
         <p:nvPr/>
       </p:nvGrpSpPr>
-      <p:grpSpPr>
-        <a:xfrm>
-          <a:off x="0" y="0"/>
-          <a:ext cx="0" cy="0"/>
-          <a:chOff x="0" y="0"/>
-          <a:chExt cx="0" cy="0"/>
-        </a:xfrm>
-      </p:grpSpPr>
+      <p:grpSpPr/>
       <p:sp>
         <p:nvSpPr>
           <p:cNvPr id="2" name="TextBox 1"/>
@@ -4614,7 +4724,6 @@
           <a:lstStyle/>
           <a:p>
             <a:pPr algn="ctr"/>
-            <a:endParaRPr/>
           </a:p>
         </p:txBody>
       </p:sp>
@@ -5000,7 +5109,7 @@
 </file>
 
 <file path=ppt/slides/slide6.xml><?xml version="1.0" encoding="utf-8"?>
-<p:sld xmlns:a="http://schemas.openxmlformats.org/drawingml/2006/main" xmlns:r="http://schemas.openxmlformats.org/officeDocument/2006/relationships" xmlns:p="http://schemas.openxmlformats.org/presentationml/2006/main">
+<p:sld xmlns:a="http://schemas.openxmlformats.org/drawingml/2006/main" xmlns:p="http://schemas.openxmlformats.org/presentationml/2006/main" xmlns:r="http://schemas.openxmlformats.org/officeDocument/2006/relationships">
   <p:cSld>
     <p:spTree>
       <p:nvGrpSpPr>
@@ -5008,14 +5117,7 @@
         <p:cNvGrpSpPr/>
         <p:nvPr/>
       </p:nvGrpSpPr>
-      <p:grpSpPr>
-        <a:xfrm>
-          <a:off x="0" y="0"/>
-          <a:ext cx="0" cy="0"/>
-          <a:chOff x="0" y="0"/>
-          <a:chExt cx="0" cy="0"/>
-        </a:xfrm>
-      </p:grpSpPr>
+      <p:grpSpPr/>
       <p:sp>
         <p:nvSpPr>
           <p:cNvPr id="2" name="TextBox 1"/>
@@ -5107,7 +5209,6 @@
           <a:lstStyle/>
           <a:p>
             <a:pPr algn="ctr"/>
-            <a:endParaRPr/>
           </a:p>
         </p:txBody>
       </p:sp>
@@ -5683,44 +5784,44 @@
         <a:sysClr val="window" lastClr="FFFFFF"/>
       </a:lt1>
       <a:dk2>
-        <a:srgbClr val="0E2841"/>
+        <a:srgbClr val="1F497D"/>
       </a:dk2>
       <a:lt2>
-        <a:srgbClr val="E8E8E8"/>
+        <a:srgbClr val="EEECE1"/>
       </a:lt2>
       <a:accent1>
-        <a:srgbClr val="156082"/>
+        <a:srgbClr val="4F81BD"/>
       </a:accent1>
       <a:accent2>
-        <a:srgbClr val="E97132"/>
+        <a:srgbClr val="C0504D"/>
       </a:accent2>
       <a:accent3>
-        <a:srgbClr val="196B24"/>
+        <a:srgbClr val="9BBB59"/>
       </a:accent3>
       <a:accent4>
-        <a:srgbClr val="0F9ED5"/>
+        <a:srgbClr val="8064A2"/>
       </a:accent4>
       <a:accent5>
-        <a:srgbClr val="A02B93"/>
+        <a:srgbClr val="4BACC6"/>
       </a:accent5>
       <a:accent6>
-        <a:srgbClr val="4EA72E"/>
+        <a:srgbClr val="F79646"/>
       </a:accent6>
       <a:hlink>
-        <a:srgbClr val="467886"/>
+        <a:srgbClr val="0000FF"/>
       </a:hlink>
       <a:folHlink>
-        <a:srgbClr val="96607D"/>
+        <a:srgbClr val="800080"/>
       </a:folHlink>
     </a:clrScheme>
     <a:fontScheme name="Office">
       <a:majorFont>
-        <a:latin typeface="Aptos Display" panose="02110004020202020204"/>
+        <a:latin typeface="Calibri"/>
         <a:ea typeface=""/>
         <a:cs typeface=""/>
-        <a:font script="Jpan" typeface="游ゴシック Light"/>
+        <a:font script="Jpan" typeface="ＭＳ Ｐゴシック"/>
         <a:font script="Hang" typeface="맑은 고딕"/>
-        <a:font script="Hans" typeface="等线 Light"/>
+        <a:font script="Hans" typeface="宋体"/>
         <a:font script="Hant" typeface="新細明體"/>
         <a:font script="Arab" typeface="Times New Roman"/>
         <a:font script="Hebr" typeface="Times New Roman"/>
@@ -5748,31 +5849,14 @@
         <a:font script="Viet" typeface="Times New Roman"/>
         <a:font script="Uigh" typeface="Microsoft Uighur"/>
         <a:font script="Geor" typeface="Sylfaen"/>
-        <a:font script="Armn" typeface="Arial"/>
-        <a:font script="Bugi" typeface="Leelawadee UI"/>
-        <a:font script="Bopo" typeface="Microsoft JhengHei"/>
-        <a:font script="Java" typeface="Javanese Text"/>
-        <a:font script="Lisu" typeface="Segoe UI"/>
-        <a:font script="Mymr" typeface="Myanmar Text"/>
-        <a:font script="Nkoo" typeface="Ebrima"/>
-        <a:font script="Olck" typeface="Nirmala UI"/>
-        <a:font script="Osma" typeface="Ebrima"/>
-        <a:font script="Phag" typeface="Phagspa"/>
-        <a:font script="Syrn" typeface="Estrangelo Edessa"/>
-        <a:font script="Syrj" typeface="Estrangelo Edessa"/>
-        <a:font script="Syre" typeface="Estrangelo Edessa"/>
-        <a:font script="Sora" typeface="Nirmala UI"/>
-        <a:font script="Tale" typeface="Microsoft Tai Le"/>
-        <a:font script="Talu" typeface="Microsoft New Tai Lue"/>
-        <a:font script="Tfng" typeface="Ebrima"/>
       </a:majorFont>
       <a:minorFont>
-        <a:latin typeface="Aptos" panose="02110004020202020204"/>
+        <a:latin typeface="Calibri"/>
         <a:ea typeface=""/>
         <a:cs typeface=""/>
-        <a:font script="Jpan" typeface="游ゴシック"/>
+        <a:font script="Jpan" typeface="ＭＳ Ｐゴシック"/>
         <a:font script="Hang" typeface="맑은 고딕"/>
-        <a:font script="Hans" typeface="等线"/>
+        <a:font script="Hans" typeface="宋体"/>
         <a:font script="Hant" typeface="新細明體"/>
         <a:font script="Arab" typeface="Arial"/>
         <a:font script="Hebr" typeface="Arial"/>
@@ -5800,23 +5884,6 @@
         <a:font script="Viet" typeface="Arial"/>
         <a:font script="Uigh" typeface="Microsoft Uighur"/>
         <a:font script="Geor" typeface="Sylfaen"/>
-        <a:font script="Armn" typeface="Arial"/>
-        <a:font script="Bugi" typeface="Leelawadee UI"/>
-        <a:font script="Bopo" typeface="Microsoft JhengHei"/>
-        <a:font script="Java" typeface="Javanese Text"/>
-        <a:font script="Lisu" typeface="Segoe UI"/>
-        <a:font script="Mymr" typeface="Myanmar Text"/>
-        <a:font script="Nkoo" typeface="Ebrima"/>
-        <a:font script="Olck" typeface="Nirmala UI"/>
-        <a:font script="Osma" typeface="Ebrima"/>
-        <a:font script="Phag" typeface="Phagspa"/>
-        <a:font script="Syrn" typeface="Estrangelo Edessa"/>
-        <a:font script="Syrj" typeface="Estrangelo Edessa"/>
-        <a:font script="Syre" typeface="Estrangelo Edessa"/>
-        <a:font script="Sora" typeface="Nirmala UI"/>
-        <a:font script="Tale" typeface="Microsoft Tai Le"/>
-        <a:font script="Talu" typeface="Microsoft New Tai Lue"/>
-        <a:font script="Tfng" typeface="Ebrima"/>
       </a:minorFont>
     </a:fontScheme>
     <a:fmtScheme name="Office">
@@ -5828,136 +5895,180 @@
           <a:gsLst>
             <a:gs pos="0">
               <a:schemeClr val="phClr">
-                <a:lumMod val="110000"/>
-                <a:satMod val="105000"/>
-                <a:tint val="67000"/>
+                <a:tint val="50000"/>
+                <a:satMod val="300000"/>
               </a:schemeClr>
             </a:gs>
-            <a:gs pos="50000">
+            <a:gs pos="35000">
               <a:schemeClr val="phClr">
-                <a:lumMod val="105000"/>
-                <a:satMod val="103000"/>
-                <a:tint val="73000"/>
+                <a:tint val="37000"/>
+                <a:satMod val="300000"/>
               </a:schemeClr>
             </a:gs>
             <a:gs pos="100000">
               <a:schemeClr val="phClr">
-                <a:lumMod val="105000"/>
-                <a:satMod val="109000"/>
-                <a:tint val="81000"/>
+                <a:tint val="15000"/>
+                <a:satMod val="350000"/>
               </a:schemeClr>
             </a:gs>
           </a:gsLst>
-          <a:lin ang="5400000" scaled="0"/>
+          <a:lin ang="16200000" scaled="1"/>
         </a:gradFill>
         <a:gradFill rotWithShape="1">
           <a:gsLst>
             <a:gs pos="0">
               <a:schemeClr val="phClr">
-                <a:satMod val="103000"/>
-                <a:lumMod val="102000"/>
-                <a:tint val="94000"/>
-              </a:schemeClr>
-            </a:gs>
-            <a:gs pos="50000">
-              <a:schemeClr val="phClr">
-                <a:satMod val="110000"/>
-                <a:lumMod val="100000"/>
+                <a:tint val="100000"/>
                 <a:shade val="100000"/>
+                <a:satMod val="130000"/>
               </a:schemeClr>
             </a:gs>
             <a:gs pos="100000">
               <a:schemeClr val="phClr">
-                <a:lumMod val="99000"/>
-                <a:satMod val="120000"/>
-                <a:shade val="78000"/>
+                <a:tint val="50000"/>
+                <a:shade val="100000"/>
+                <a:satMod val="350000"/>
               </a:schemeClr>
             </a:gs>
           </a:gsLst>
-          <a:lin ang="5400000" scaled="0"/>
+          <a:lin ang="16200000" scaled="0"/>
         </a:gradFill>
       </a:fillStyleLst>
       <a:lnStyleLst>
-        <a:ln w="12700" cap="flat" cmpd="sng" algn="ctr">
+        <a:ln w="9525" cap="flat" cmpd="sng" algn="ctr">
           <a:solidFill>
-            <a:schemeClr val="phClr"/>
+            <a:schemeClr val="phClr">
+              <a:shade val="95000"/>
+              <a:satMod val="105000"/>
+            </a:schemeClr>
           </a:solidFill>
           <a:prstDash val="solid"/>
-          <a:miter lim="800000"/>
-        </a:ln>
-        <a:ln w="19050" cap="flat" cmpd="sng" algn="ctr">
-          <a:solidFill>
-            <a:schemeClr val="phClr"/>
-          </a:solidFill>
-          <a:prstDash val="solid"/>
-          <a:miter lim="800000"/>
         </a:ln>
         <a:ln w="25400" cap="flat" cmpd="sng" algn="ctr">
           <a:solidFill>
             <a:schemeClr val="phClr"/>
           </a:solidFill>
           <a:prstDash val="solid"/>
-          <a:miter lim="800000"/>
+        </a:ln>
+        <a:ln w="38100" cap="flat" cmpd="sng" algn="ctr">
+          <a:solidFill>
+            <a:schemeClr val="phClr"/>
+          </a:solidFill>
+          <a:prstDash val="solid"/>
         </a:ln>
       </a:lnStyleLst>
       <a:effectStyleLst>
         <a:effectStyle>
-          <a:effectLst/>
-        </a:effectStyle>
-        <a:effectStyle>
-          <a:effectLst/>
+          <a:effectLst>
+            <a:outerShdw blurRad="40000" dist="20000" dir="5400000" rotWithShape="0">
+              <a:srgbClr val="000000">
+                <a:alpha val="38000"/>
+              </a:srgbClr>
+            </a:outerShdw>
+          </a:effectLst>
         </a:effectStyle>
         <a:effectStyle>
           <a:effectLst>
-            <a:outerShdw blurRad="57150" dist="19050" dir="5400000" algn="ctr" rotWithShape="0">
+            <a:outerShdw blurRad="40000" dist="23000" dir="5400000" rotWithShape="0">
               <a:srgbClr val="000000">
-                <a:alpha val="63000"/>
+                <a:alpha val="35000"/>
               </a:srgbClr>
             </a:outerShdw>
           </a:effectLst>
+        </a:effectStyle>
+        <a:effectStyle>
+          <a:effectLst>
+            <a:outerShdw blurRad="40000" dist="23000" dir="5400000" rotWithShape="0">
+              <a:srgbClr val="000000">
+                <a:alpha val="35000"/>
+              </a:srgbClr>
+            </a:outerShdw>
+          </a:effectLst>
+          <a:scene3d>
+            <a:camera prst="orthographicFront">
+              <a:rot lat="0" lon="0" rev="0"/>
+            </a:camera>
+            <a:lightRig rig="threePt" dir="t">
+              <a:rot lat="0" lon="0" rev="1200000"/>
+            </a:lightRig>
+          </a:scene3d>
+          <a:sp3d>
+            <a:bevelT w="63500" h="25400"/>
+          </a:sp3d>
         </a:effectStyle>
       </a:effectStyleLst>
       <a:bgFillStyleLst>
         <a:solidFill>
           <a:schemeClr val="phClr"/>
         </a:solidFill>
-        <a:solidFill>
-          <a:schemeClr val="phClr">
-            <a:tint val="95000"/>
-            <a:satMod val="170000"/>
-          </a:schemeClr>
-        </a:solidFill>
         <a:gradFill rotWithShape="1">
           <a:gsLst>
             <a:gs pos="0">
               <a:schemeClr val="phClr">
-                <a:tint val="93000"/>
-                <a:satMod val="150000"/>
-                <a:shade val="98000"/>
-                <a:lumMod val="102000"/>
+                <a:tint val="40000"/>
+                <a:satMod val="350000"/>
               </a:schemeClr>
             </a:gs>
-            <a:gs pos="50000">
+            <a:gs pos="40000">
               <a:schemeClr val="phClr">
-                <a:tint val="98000"/>
-                <a:satMod val="130000"/>
-                <a:shade val="90000"/>
-                <a:lumMod val="103000"/>
+                <a:tint val="45000"/>
+                <a:shade val="99000"/>
+                <a:satMod val="350000"/>
               </a:schemeClr>
             </a:gs>
             <a:gs pos="100000">
               <a:schemeClr val="phClr">
-                <a:shade val="63000"/>
-                <a:satMod val="120000"/>
+                <a:shade val="20000"/>
+                <a:satMod val="255000"/>
               </a:schemeClr>
             </a:gs>
           </a:gsLst>
-          <a:lin ang="5400000" scaled="0"/>
+          <a:path path="circle">
+            <a:fillToRect l="50000" t="-80000" r="50000" b="180000"/>
+          </a:path>
+        </a:gradFill>
+        <a:gradFill rotWithShape="1">
+          <a:gsLst>
+            <a:gs pos="0">
+              <a:schemeClr val="phClr">
+                <a:tint val="80000"/>
+                <a:satMod val="300000"/>
+              </a:schemeClr>
+            </a:gs>
+            <a:gs pos="100000">
+              <a:schemeClr val="phClr">
+                <a:shade val="30000"/>
+                <a:satMod val="200000"/>
+              </a:schemeClr>
+            </a:gs>
+          </a:gsLst>
+          <a:path path="circle">
+            <a:fillToRect l="50000" t="50000" r="50000" b="50000"/>
+          </a:path>
         </a:gradFill>
       </a:bgFillStyleLst>
     </a:fmtScheme>
   </a:themeElements>
   <a:objectDefaults>
+    <a:spDef>
+      <a:spPr/>
+      <a:bodyPr/>
+      <a:lstStyle/>
+      <a:style>
+        <a:lnRef idx="1">
+          <a:schemeClr val="accent1"/>
+        </a:lnRef>
+        <a:fillRef idx="3">
+          <a:schemeClr val="accent1"/>
+        </a:fillRef>
+        <a:effectRef idx="2">
+          <a:schemeClr val="accent1"/>
+        </a:effectRef>
+        <a:fontRef idx="minor">
+          <a:schemeClr val="lt1"/>
+        </a:fontRef>
+      </a:style>
+    </a:spDef>
     <a:lnDef>
       <a:spPr/>
       <a:bodyPr/>
@@ -5979,10 +6090,5 @@
     </a:lnDef>
   </a:objectDefaults>
   <a:extraClrSchemeLst/>
-  <a:extLst>
-    <a:ext uri="{05A4C25C-085E-4340-85A3-A5531E510DB2}">
-      <thm15:themeFamily xmlns:thm15="http://schemas.microsoft.com/office/thememl/2012/main" name="Office Theme" id="{2E142A2C-CD16-42D6-873A-C26D2A0506FA}" vid="{1BDDFF52-6CD6-40A5-AB3C-68EB2F1E4D0A}"/>
-    </a:ext>
-  </a:extLst>
 </a:theme>
 </file>
</xml_diff>